<commit_message>
Switch July trend charts to May-Jul window
Co-Authored-By: Claude Opus 4.8 <noreply@anthropic.com>
Claude-Session: https://claude.ai/code/session_01HTHNkMyy3hCJ7Wqf5x3kDZ
</commit_message>
<xml_diff>
--- a/board_review_q2_2026/july_update/TML_July_Update.pptx
+++ b/board_review_q2_2026/july_update/TML_July_Update.pptx
@@ -6550,55 +6550,7 @@
                 <a:cs typeface="Manrope"/>
                 <a:sym typeface="Manrope"/>
               </a:rPr>
-              <a:t>TREND  (</a:t>
-            </a:r>
-            <a:r>
-              <a:rPr b="1" lang="en" sz="950">
-                <a:solidFill>
-                  <a:schemeClr val="dk1"/>
-                </a:solidFill>
-                <a:latin typeface="Manrope"/>
-                <a:ea typeface="Manrope"/>
-                <a:cs typeface="Manrope"/>
-                <a:sym typeface="Manrope"/>
-              </a:rPr>
-              <a:t>Apr</a:t>
-            </a:r>
-            <a:r>
-              <a:rPr b="1" i="0" lang="en" sz="950" u="none" cap="none" strike="noStrike">
-                <a:solidFill>
-                  <a:schemeClr val="dk1"/>
-                </a:solidFill>
-                <a:latin typeface="Manrope"/>
-                <a:ea typeface="Manrope"/>
-                <a:cs typeface="Manrope"/>
-                <a:sym typeface="Manrope"/>
-              </a:rPr>
-              <a:t>–Ju</a:t>
-            </a:r>
-            <a:r>
-              <a:rPr b="1" lang="en" sz="950">
-                <a:solidFill>
-                  <a:schemeClr val="dk1"/>
-                </a:solidFill>
-                <a:latin typeface="Manrope"/>
-                <a:ea typeface="Manrope"/>
-                <a:cs typeface="Manrope"/>
-                <a:sym typeface="Manrope"/>
-              </a:rPr>
-              <a:t>l</a:t>
-            </a:r>
-            <a:r>
-              <a:rPr b="1" i="0" lang="en" sz="950" u="none" cap="none" strike="noStrike">
-                <a:solidFill>
-                  <a:schemeClr val="dk1"/>
-                </a:solidFill>
-                <a:latin typeface="Manrope"/>
-                <a:ea typeface="Manrope"/>
-                <a:cs typeface="Manrope"/>
-                <a:sym typeface="Manrope"/>
-              </a:rPr>
-              <a:t>'26)</a:t>
+              <a:t>TREND  (May–Jul'26)</a:t>
             </a:r>
             <a:endParaRPr b="0" i="0" sz="1400" u="none" cap="none" strike="noStrike">
               <a:solidFill>

</xml_diff>

<commit_message>
July slide: refresh Progress + Next-Focus from Linear (Carrier Matching)
Pull real Jun->Jul completed stories and in-progress/planned work per project:
- Ledger shipped in July (immutable trip-level ledger, FO/LSP wallets,
  automated TDS; Phase-1 foundation live) -> badge now 'Phase-1 live'
- Ops: automated advance payments for Gold/Silver FOs shipped; SIM-consent
  moved to Next Focus (still in progress)
- FO App / Fulfilment / Supply progress + next-focus refreshed from issues
- Trend charts May-Jul; header JUN-JUL PROGRESS

Co-Authored-By: Claude Opus 4.8 <noreply@anthropic.com>
Claude-Session: https://claude.ai/code/session_01HTHNkMyy3hCJ7Wqf5x3kDZ
</commit_message>
<xml_diff>
--- a/board_review_q2_2026/july_update/TML_July_Update.pptx
+++ b/board_review_q2_2026/july_update/TML_July_Update.pptx
@@ -6829,31 +6829,7 @@
                 <a:cs typeface="Manrope"/>
                 <a:sym typeface="Manrope"/>
               </a:rPr>
-              <a:t>•  Improved </a:t>
-            </a:r>
-            <a:r>
-              <a:rPr b="0" i="0" lang="en" sz="800" u="none" cap="none" strike="noStrike">
-                <a:solidFill>
-                  <a:srgbClr val="25303B"/>
-                </a:solidFill>
-                <a:latin typeface="Manrope"/>
-                <a:ea typeface="Manrope"/>
-                <a:cs typeface="Manrope"/>
-                <a:sym typeface="Manrope"/>
-              </a:rPr>
-              <a:t> load experience</a:t>
-            </a:r>
-            <a:r>
-              <a:rPr b="0" i="0" lang="en" sz="800" u="none" cap="none" strike="noStrike">
-                <a:solidFill>
-                  <a:srgbClr val="25303B"/>
-                </a:solidFill>
-                <a:latin typeface="Manrope"/>
-                <a:ea typeface="Manrope"/>
-                <a:cs typeface="Manrope"/>
-                <a:sym typeface="Manrope"/>
-              </a:rPr>
-              <a:t> for FOs based on vehicle location</a:t>
+              <a:t>•  POD details + payment status &amp; timelines in app</a:t>
             </a:r>
             <a:endParaRPr b="0" i="0" sz="800" u="none" cap="none" strike="noStrike">
               <a:solidFill>
@@ -6893,7 +6869,7 @@
                 <a:cs typeface="Manrope"/>
                 <a:sym typeface="Manrope"/>
               </a:rPr>
-              <a:t>•  Visibility for payment deductions, My bids</a:t>
+              <a:t>•  Proactive POD dispute/deduction alerts + re-upload</a:t>
             </a:r>
             <a:endParaRPr b="0" i="0" sz="800" u="none" cap="none" strike="noStrike">
               <a:solidFill>
@@ -6933,7 +6909,7 @@
                 <a:cs typeface="Manrope"/>
                 <a:sym typeface="Manrope"/>
               </a:rPr>
-              <a:t>•  Customer support on App</a:t>
+              <a:t>•  DAU 271 → 298 (+10%); MAU 1,377 → 1,573 (+14%)</a:t>
             </a:r>
             <a:endParaRPr b="0" i="0" sz="800" u="none" cap="none" strike="noStrike">
               <a:solidFill>
@@ -6943,46 +6919,6 @@
               <a:ea typeface="Manrope"/>
               <a:cs typeface="Manrope"/>
               <a:sym typeface="Manrope"/>
-            </a:endParaRPr>
-          </a:p>
-          <a:p>
-            <a:pPr indent="-137160" lvl="0" marL="137160" marR="0" rtl="0" algn="l">
-              <a:lnSpc>
-                <a:spcPct val="102000"/>
-              </a:lnSpc>
-              <a:spcBef>
-                <a:spcPts val="250"/>
-              </a:spcBef>
-              <a:spcAft>
-                <a:spcPts val="0"/>
-              </a:spcAft>
-              <a:buClr>
-                <a:srgbClr val="000000"/>
-              </a:buClr>
-              <a:buSzPts val="800"/>
-              <a:buFont typeface="Arial"/>
-              <a:buNone/>
-            </a:pPr>
-            <a:r>
-              <a:rPr b="0" i="0" lang="en" sz="800" u="none" cap="none" strike="noStrike">
-                <a:solidFill>
-                  <a:schemeClr val="dk1"/>
-                </a:solidFill>
-                <a:latin typeface="Manrope"/>
-                <a:ea typeface="Manrope"/>
-                <a:cs typeface="Manrope"/>
-                <a:sym typeface="Manrope"/>
-              </a:rPr>
-              <a:t>•  DAU 271 → 298 (+10%); MAU 1,377 → 1,573 (+14%)</a:t>
-            </a:r>
-            <a:endParaRPr b="0" i="0" sz="800" u="none" cap="none" strike="noStrike">
-              <a:solidFill>
-                <a:srgbClr val="000000"/>
-              </a:solidFill>
-              <a:latin typeface="Arial"/>
-              <a:ea typeface="Arial"/>
-              <a:cs typeface="Arial"/>
-              <a:sym typeface="Arial"/>
             </a:endParaRPr>
           </a:p>
         </p:txBody>
@@ -7057,7 +6993,7 @@
                 <a:spcPct val="102000"/>
               </a:lnSpc>
               <a:spcBef>
-                <a:spcPts val="250"/>
+                <a:spcPts val="0"/>
               </a:spcBef>
               <a:spcAft>
                 <a:spcPts val="0"/>
@@ -7079,40 +7015,16 @@
                 <a:cs typeface="Manrope"/>
                 <a:sym typeface="Manrope"/>
               </a:rPr>
-              <a:t>›  Build Trip payment statement </a:t>
+              <a:t>›  Reach PSA directly for placement (in build)</a:t>
             </a:r>
-            <a:r>
-              <a:rPr b="0" i="0" lang="en" sz="819" u="none" cap="none" strike="noStrike">
-                <a:solidFill>
-                  <a:schemeClr val="dk1"/>
-                </a:solidFill>
-                <a:latin typeface="Manrope"/>
-                <a:ea typeface="Manrope"/>
-                <a:cs typeface="Manrope"/>
-                <a:sym typeface="Manrope"/>
-              </a:rPr>
-              <a:t>+ load discovery</a:t>
-            </a:r>
-            <a:r>
-              <a:rPr b="0" i="0" lang="en" sz="819" u="none" cap="none" strike="noStrike">
-                <a:solidFill>
-                  <a:schemeClr val="dk1"/>
-                </a:solidFill>
-                <a:latin typeface="Manrope"/>
-                <a:ea typeface="Manrope"/>
-                <a:cs typeface="Manrope"/>
-                <a:sym typeface="Manrope"/>
-              </a:rPr>
-              <a:t> for workable lanes only </a:t>
-            </a:r>
-            <a:endParaRPr b="0" i="0" sz="819" u="none" cap="none" strike="noStrike">
+            <a:endParaRPr b="0" i="0" sz="1400" u="none" cap="none" strike="noStrike">
               <a:solidFill>
-                <a:schemeClr val="dk1"/>
+                <a:srgbClr val="000000"/>
               </a:solidFill>
-              <a:latin typeface="Manrope"/>
-              <a:ea typeface="Manrope"/>
-              <a:cs typeface="Manrope"/>
-              <a:sym typeface="Manrope"/>
+              <a:latin typeface="Arial"/>
+              <a:ea typeface="Arial"/>
+              <a:cs typeface="Arial"/>
+              <a:sym typeface="Arial"/>
             </a:endParaRPr>
           </a:p>
           <a:p>
@@ -7121,7 +7033,7 @@
                 <a:spcPct val="102000"/>
               </a:lnSpc>
               <a:spcBef>
-                <a:spcPts val="250"/>
+                <a:spcPts val="0"/>
               </a:spcBef>
               <a:spcAft>
                 <a:spcPts val="0"/>
@@ -7143,16 +7055,16 @@
                 <a:cs typeface="Manrope"/>
                 <a:sym typeface="Manrope"/>
               </a:rPr>
-              <a:t>&gt; Request for advance directly from App</a:t>
+              <a:t>›  Trip payment statement + in-app advance</a:t>
             </a:r>
-            <a:endParaRPr b="0" i="0" sz="819" u="none" cap="none" strike="noStrike">
+            <a:endParaRPr b="0" i="0" sz="1400" u="none" cap="none" strike="noStrike">
               <a:solidFill>
-                <a:schemeClr val="dk1"/>
+                <a:srgbClr val="000000"/>
               </a:solidFill>
-              <a:latin typeface="Manrope"/>
-              <a:ea typeface="Manrope"/>
-              <a:cs typeface="Manrope"/>
-              <a:sym typeface="Manrope"/>
+              <a:latin typeface="Arial"/>
+              <a:ea typeface="Arial"/>
+              <a:cs typeface="Arial"/>
+              <a:sym typeface="Arial"/>
             </a:endParaRPr>
           </a:p>
         </p:txBody>
@@ -7342,7 +7254,7 @@
                 <a:cs typeface="Manrope"/>
                 <a:sym typeface="Manrope"/>
               </a:rPr>
-              <a:t>• Relevant inventory matching against demands</a:t>
+              <a:t>•  Near-match logic + match quality on demand list</a:t>
             </a:r>
             <a:endParaRPr b="0" i="0" sz="800" u="none" cap="none" strike="noStrike">
               <a:solidFill>
@@ -7382,7 +7294,7 @@
                 <a:cs typeface="Manrope"/>
                 <a:sym typeface="Manrope"/>
               </a:rPr>
-              <a:t>• Simplify the placement experience in CRM</a:t>
+              <a:t>•  Supplier availability: lane-specific vs unavailable</a:t>
             </a:r>
             <a:endParaRPr b="0" i="0" sz="800" u="none" cap="none" strike="noStrike">
               <a:solidFill>
@@ -7395,12 +7307,12 @@
             </a:endParaRPr>
           </a:p>
           <a:p>
-            <a:pPr indent="0" lvl="0" marL="0" marR="0" rtl="0" algn="l">
+            <a:pPr indent="-137160" lvl="0" marL="137160" marR="0" rtl="0" algn="l">
               <a:lnSpc>
                 <a:spcPct val="102000"/>
               </a:lnSpc>
               <a:spcBef>
-                <a:spcPts val="250"/>
+                <a:spcPts val="0"/>
               </a:spcBef>
               <a:spcAft>
                 <a:spcPts val="0"/>
@@ -7413,16 +7325,25 @@
               <a:buNone/>
             </a:pPr>
             <a:r>
-              <a:t/>
+              <a:rPr b="0" i="0" lang="en" sz="800" u="none" cap="none" strike="noStrike">
+                <a:solidFill>
+                  <a:srgbClr val="25303B"/>
+                </a:solidFill>
+                <a:latin typeface="Manrope"/>
+                <a:ea typeface="Manrope"/>
+                <a:cs typeface="Manrope"/>
+                <a:sym typeface="Manrope"/>
+              </a:rPr>
+              <a:t>•  Agents onboarded (Clerk) for lane assignment</a:t>
             </a:r>
             <a:endParaRPr b="0" i="0" sz="800" u="none" cap="none" strike="noStrike">
               <a:solidFill>
-                <a:srgbClr val="000000"/>
+                <a:srgbClr val="25303B"/>
               </a:solidFill>
-              <a:latin typeface="Arial"/>
-              <a:ea typeface="Arial"/>
-              <a:cs typeface="Arial"/>
-              <a:sym typeface="Arial"/>
+              <a:latin typeface="Manrope"/>
+              <a:ea typeface="Manrope"/>
+              <a:cs typeface="Manrope"/>
+              <a:sym typeface="Manrope"/>
             </a:endParaRPr>
           </a:p>
         </p:txBody>
@@ -7479,8 +7400,36 @@
                 <a:cs typeface="Manrope"/>
                 <a:sym typeface="Manrope"/>
               </a:rPr>
-              <a:t>›  Push </a:t>
+              <a:t>›  Agent → lane auto-assignment (shipped)</a:t>
             </a:r>
+            <a:endParaRPr b="0" i="0" sz="819" u="none" cap="none" strike="noStrike">
+              <a:solidFill>
+                <a:schemeClr val="dk1"/>
+              </a:solidFill>
+              <a:latin typeface="Manrope"/>
+              <a:ea typeface="Manrope"/>
+              <a:cs typeface="Manrope"/>
+              <a:sym typeface="Manrope"/>
+            </a:endParaRPr>
+          </a:p>
+          <a:p>
+            <a:pPr indent="0" lvl="0" marL="0" marR="0" rtl="0" algn="l">
+              <a:lnSpc>
+                <a:spcPct val="102000"/>
+              </a:lnSpc>
+              <a:spcBef>
+                <a:spcPts val="250"/>
+              </a:spcBef>
+              <a:spcAft>
+                <a:spcPts val="0"/>
+              </a:spcAft>
+              <a:buClr>
+                <a:srgbClr val="000000"/>
+              </a:buClr>
+              <a:buSzPts val="818"/>
+              <a:buFont typeface="Arial"/>
+              <a:buNone/>
+            </a:pPr>
             <a:r>
               <a:rPr b="0" i="0" lang="en" sz="819" u="none" cap="none" strike="noStrike">
                 <a:solidFill>
@@ -7491,7 +7440,47 @@
                 <a:cs typeface="Manrope"/>
                 <a:sym typeface="Manrope"/>
               </a:rPr>
-              <a:t>placeable fulfilment to 20% on network lanes</a:t>
+              <a:t>›  Prioritise demand list; Demand-Bot context (in build)</a:t>
+            </a:r>
+            <a:endParaRPr b="0" i="0" sz="819" u="none" cap="none" strike="noStrike">
+              <a:solidFill>
+                <a:schemeClr val="dk1"/>
+              </a:solidFill>
+              <a:latin typeface="Manrope"/>
+              <a:ea typeface="Manrope"/>
+              <a:cs typeface="Manrope"/>
+              <a:sym typeface="Manrope"/>
+            </a:endParaRPr>
+          </a:p>
+          <a:p>
+            <a:pPr indent="0" lvl="0" marL="0" marR="0" rtl="0" algn="l">
+              <a:lnSpc>
+                <a:spcPct val="102000"/>
+              </a:lnSpc>
+              <a:spcBef>
+                <a:spcPts val="250"/>
+              </a:spcBef>
+              <a:spcAft>
+                <a:spcPts val="0"/>
+              </a:spcAft>
+              <a:buClr>
+                <a:srgbClr val="000000"/>
+              </a:buClr>
+              <a:buSzPts val="818"/>
+              <a:buFont typeface="Arial"/>
+              <a:buNone/>
+            </a:pPr>
+            <a:r>
+              <a:rPr b="0" i="0" lang="en" sz="819" u="none" cap="none" strike="noStrike">
+                <a:solidFill>
+                  <a:schemeClr val="dk1"/>
+                </a:solidFill>
+                <a:latin typeface="Manrope"/>
+                <a:ea typeface="Manrope"/>
+                <a:cs typeface="Manrope"/>
+                <a:sym typeface="Manrope"/>
+              </a:rPr>
+              <a:t>›  Push network-lane fulfilment → 20%</a:t>
             </a:r>
             <a:endParaRPr b="0" i="0" sz="819" u="none" cap="none" strike="noStrike">
               <a:solidFill>
@@ -7688,7 +7677,7 @@
                 <a:cs typeface="Manrope"/>
                 <a:sym typeface="Manrope"/>
               </a:rPr>
-              <a:t>• Enabled  automated inventory creation via Agentic AI  in multi-lang</a:t>
+              <a:t>•  Automated AI calling for live &amp; potential inventory (multi-lang)</a:t>
             </a:r>
             <a:endParaRPr b="0" i="0" sz="819" u="none" cap="none" strike="noStrike">
               <a:solidFill>
@@ -7728,7 +7717,7 @@
                 <a:cs typeface="Manrope"/>
                 <a:sym typeface="Manrope"/>
               </a:rPr>
-              <a:t>• Multiple refinements to get quality inventory from  engaged FOs</a:t>
+              <a:t>•  WhatsApp fallback + callback; cooldown filtering</a:t>
             </a:r>
             <a:endParaRPr b="0" i="0" sz="819" u="none" cap="none" strike="noStrike">
               <a:solidFill>
@@ -7746,7 +7735,7 @@
                 <a:spcPct val="102000"/>
               </a:lnSpc>
               <a:spcBef>
-                <a:spcPts val="250"/>
+                <a:spcPts val="0"/>
               </a:spcBef>
               <a:spcAft>
                 <a:spcPts val="0"/>
@@ -7768,16 +7757,16 @@
                 <a:cs typeface="Manrope"/>
                 <a:sym typeface="Manrope"/>
               </a:rPr>
-              <a:t>• AI drives ~65% of inventory</a:t>
+              <a:t>•  AI drives ~65% of inventory</a:t>
             </a:r>
-            <a:endParaRPr b="0" i="0" sz="1400" u="none" cap="none" strike="noStrike">
+            <a:endParaRPr b="0" i="0" sz="819" u="none" cap="none" strike="noStrike">
               <a:solidFill>
-                <a:srgbClr val="000000"/>
+                <a:schemeClr val="dk1"/>
               </a:solidFill>
-              <a:latin typeface="Arial"/>
-              <a:ea typeface="Arial"/>
-              <a:cs typeface="Arial"/>
-              <a:sym typeface="Arial"/>
+              <a:latin typeface="Manrope"/>
+              <a:ea typeface="Manrope"/>
+              <a:cs typeface="Manrope"/>
+              <a:sym typeface="Manrope"/>
             </a:endParaRPr>
           </a:p>
         </p:txBody>
@@ -7834,7 +7823,47 @@
                 <a:cs typeface="Manrope"/>
                 <a:sym typeface="Manrope"/>
               </a:rPr>
-              <a:t>›  Focus inventory creation on network lane to 1500/mo inventory</a:t>
+              <a:t>›  Inventory creation on network lanes → 1,500/mo</a:t>
+            </a:r>
+            <a:endParaRPr b="0" i="0" sz="819" u="none" cap="none" strike="noStrike">
+              <a:solidFill>
+                <a:srgbClr val="25303B"/>
+              </a:solidFill>
+              <a:latin typeface="Manrope"/>
+              <a:ea typeface="Manrope"/>
+              <a:cs typeface="Manrope"/>
+              <a:sym typeface="Manrope"/>
+            </a:endParaRPr>
+          </a:p>
+          <a:p>
+            <a:pPr indent="-137160" lvl="0" marL="137160" marR="0" rtl="0" algn="l">
+              <a:lnSpc>
+                <a:spcPct val="102000"/>
+              </a:lnSpc>
+              <a:spcBef>
+                <a:spcPts val="0"/>
+              </a:spcBef>
+              <a:spcAft>
+                <a:spcPts val="0"/>
+              </a:spcAft>
+              <a:buClr>
+                <a:srgbClr val="000000"/>
+              </a:buClr>
+              <a:buSzPts val="818"/>
+              <a:buFont typeface="Arial"/>
+              <a:buNone/>
+            </a:pPr>
+            <a:r>
+              <a:rPr b="0" i="0" lang="en" sz="819" u="none" cap="none" strike="noStrike">
+                <a:solidFill>
+                  <a:srgbClr val="25303B"/>
+                </a:solidFill>
+                <a:latin typeface="Manrope"/>
+                <a:ea typeface="Manrope"/>
+                <a:cs typeface="Manrope"/>
+                <a:sym typeface="Manrope"/>
+              </a:rPr>
+              <a:t>›  Improve inventory quality &amp; conversion</a:t>
             </a:r>
             <a:endParaRPr b="0" i="0" sz="819" u="none" cap="none" strike="noStrike">
               <a:solidFill>
@@ -8100,7 +8129,7 @@
                 <a:cs typeface="Manrope"/>
                 <a:sym typeface="Manrope"/>
               </a:rPr>
-              <a:t>•  Automated Vahan verification &amp; journey updates in LSP WhatsApp group, </a:t>
+              <a:t>•  Automated advance payments for Gold/Silver FOs (validation → approval → auto-release)</a:t>
             </a:r>
             <a:endParaRPr b="0" i="0" sz="819" u="none" cap="none" strike="noStrike">
               <a:solidFill>
@@ -8140,16 +8169,56 @@
                 <a:cs typeface="Manrope"/>
                 <a:sym typeface="Manrope"/>
               </a:rPr>
-              <a:t>•  Automated SIM-consent via AI CT</a:t>
+              <a:t>•  WhatsApp-disconnect auto-reminders for CRM users</a:t>
             </a:r>
-            <a:endParaRPr b="0" i="0" sz="1400" u="none" cap="none" strike="noStrike">
+            <a:endParaRPr b="0" i="0" sz="819" u="none" cap="none" strike="noStrike">
               <a:solidFill>
+                <a:schemeClr val="dk1"/>
+              </a:solidFill>
+              <a:latin typeface="Manrope"/>
+              <a:ea typeface="Manrope"/>
+              <a:cs typeface="Manrope"/>
+              <a:sym typeface="Manrope"/>
+            </a:endParaRPr>
+          </a:p>
+          <a:p>
+            <a:pPr indent="-137160" lvl="0" marL="137160" marR="0" rtl="0" algn="l">
+              <a:lnSpc>
+                <a:spcPct val="102000"/>
+              </a:lnSpc>
+              <a:spcBef>
+                <a:spcPts val="0"/>
+              </a:spcBef>
+              <a:spcAft>
+                <a:spcPts val="0"/>
+              </a:spcAft>
+              <a:buClr>
                 <a:srgbClr val="000000"/>
+              </a:buClr>
+              <a:buSzPts val="818"/>
+              <a:buFont typeface="Arial"/>
+              <a:buNone/>
+            </a:pPr>
+            <a:r>
+              <a:rPr b="0" i="0" lang="en" sz="819" u="none" cap="none" strike="noStrike">
+                <a:solidFill>
+                  <a:schemeClr val="dk1"/>
+                </a:solidFill>
+                <a:latin typeface="Manrope"/>
+                <a:ea typeface="Manrope"/>
+                <a:cs typeface="Manrope"/>
+                <a:sym typeface="Manrope"/>
+              </a:rPr>
+              <a:t>•  Vahan verification &amp; journey updates in LSP WhatsApp</a:t>
+            </a:r>
+            <a:endParaRPr b="0" i="0" sz="819" u="none" cap="none" strike="noStrike">
+              <a:solidFill>
+                <a:schemeClr val="dk1"/>
               </a:solidFill>
-              <a:latin typeface="Arial"/>
-              <a:ea typeface="Arial"/>
-              <a:cs typeface="Arial"/>
-              <a:sym typeface="Arial"/>
+              <a:latin typeface="Manrope"/>
+              <a:ea typeface="Manrope"/>
+              <a:cs typeface="Manrope"/>
+              <a:sym typeface="Manrope"/>
             </a:endParaRPr>
           </a:p>
         </p:txBody>
@@ -8206,7 +8275,7 @@
                 <a:cs typeface="Manrope"/>
                 <a:sym typeface="Manrope"/>
               </a:rPr>
-              <a:t>›  FO document collection via App</a:t>
+              <a:t>›  Automate SIM-consent, pre-transit (in build)</a:t>
             </a:r>
             <a:endParaRPr b="0" i="0" sz="1400" u="none" cap="none" strike="noStrike">
               <a:solidFill>
@@ -8224,7 +8293,7 @@
                 <a:spcPct val="102000"/>
               </a:lnSpc>
               <a:spcBef>
-                <a:spcPts val="250"/>
+                <a:spcPts val="0"/>
               </a:spcBef>
               <a:spcAft>
                 <a:spcPts val="0"/>
@@ -8246,7 +8315,7 @@
                 <a:cs typeface="Manrope"/>
                 <a:sym typeface="Manrope"/>
               </a:rPr>
-              <a:t>›  Transit-delay detection &amp; automated follow up with LSP / FO</a:t>
+              <a:t>›  FO doc collection via App; transit-delay detection</a:t>
             </a:r>
             <a:endParaRPr b="0" i="0" sz="1400" u="none" cap="none" strike="noStrike">
               <a:solidFill>
@@ -8264,7 +8333,7 @@
                 <a:spcPct val="102000"/>
               </a:lnSpc>
               <a:spcBef>
-                <a:spcPts val="250"/>
+                <a:spcPts val="0"/>
               </a:spcBef>
               <a:spcAft>
                 <a:spcPts val="0"/>
@@ -8286,16 +8355,16 @@
                 <a:cs typeface="Manrope"/>
                 <a:sym typeface="Manrope"/>
               </a:rPr>
-              <a:t>&gt;  Automate TDS calculation </a:t>
+              <a:t>›  Auto-create Pylon tickets from LSP WhatsApp (POC)</a:t>
             </a:r>
-            <a:endParaRPr b="0" i="0" sz="819" u="none" cap="none" strike="noStrike">
+            <a:endParaRPr b="0" i="0" sz="1400" u="none" cap="none" strike="noStrike">
               <a:solidFill>
-                <a:schemeClr val="dk1"/>
+                <a:srgbClr val="000000"/>
               </a:solidFill>
-              <a:latin typeface="Manrope"/>
-              <a:ea typeface="Manrope"/>
-              <a:cs typeface="Manrope"/>
-              <a:sym typeface="Manrope"/>
+              <a:latin typeface="Arial"/>
+              <a:ea typeface="Arial"/>
+              <a:cs typeface="Arial"/>
+              <a:sym typeface="Arial"/>
             </a:endParaRPr>
           </a:p>
         </p:txBody>
@@ -8483,7 +8552,87 @@
                 <a:cs typeface="Manrope"/>
                 <a:sym typeface="Manrope"/>
               </a:rPr>
-              <a:t>•  Design and Build  trip-level &amp; party-level ledger</a:t>
+              <a:t>•  Immutable trip-level ledger — Net Payable/Receivable (live)</a:t>
+            </a:r>
+            <a:endParaRPr b="0" i="0" sz="1400" u="none" cap="none" strike="noStrike">
+              <a:solidFill>
+                <a:srgbClr val="000000"/>
+              </a:solidFill>
+              <a:latin typeface="Arial"/>
+              <a:ea typeface="Arial"/>
+              <a:cs typeface="Arial"/>
+              <a:sym typeface="Arial"/>
+            </a:endParaRPr>
+          </a:p>
+          <a:p>
+            <a:pPr indent="-137160" lvl="0" marL="137160" marR="0" rtl="0" algn="l">
+              <a:lnSpc>
+                <a:spcPct val="102000"/>
+              </a:lnSpc>
+              <a:spcBef>
+                <a:spcPts val="0"/>
+              </a:spcBef>
+              <a:spcAft>
+                <a:spcPts val="0"/>
+              </a:spcAft>
+              <a:buClr>
+                <a:srgbClr val="000000"/>
+              </a:buClr>
+              <a:buSzPts val="818"/>
+              <a:buFont typeface="Arial"/>
+              <a:buNone/>
+            </a:pPr>
+            <a:r>
+              <a:rPr b="0" i="0" lang="en" sz="819" u="none" cap="none" strike="noStrike">
+                <a:solidFill>
+                  <a:srgbClr val="25303B"/>
+                </a:solidFill>
+                <a:latin typeface="Manrope"/>
+                <a:ea typeface="Manrope"/>
+                <a:cs typeface="Manrope"/>
+                <a:sym typeface="Manrope"/>
+              </a:rPr>
+              <a:t>•  FO/LSP wallets + overpayment settlement; automated TDS</a:t>
+            </a:r>
+            <a:endParaRPr b="0" i="0" sz="1400" u="none" cap="none" strike="noStrike">
+              <a:solidFill>
+                <a:srgbClr val="000000"/>
+              </a:solidFill>
+              <a:latin typeface="Arial"/>
+              <a:ea typeface="Arial"/>
+              <a:cs typeface="Arial"/>
+              <a:sym typeface="Arial"/>
+            </a:endParaRPr>
+          </a:p>
+          <a:p>
+            <a:pPr indent="-137160" lvl="0" marL="137160" marR="0" rtl="0" algn="l">
+              <a:lnSpc>
+                <a:spcPct val="102000"/>
+              </a:lnSpc>
+              <a:spcBef>
+                <a:spcPts val="0"/>
+              </a:spcBef>
+              <a:spcAft>
+                <a:spcPts val="0"/>
+              </a:spcAft>
+              <a:buClr>
+                <a:srgbClr val="000000"/>
+              </a:buClr>
+              <a:buSzPts val="818"/>
+              <a:buFont typeface="Arial"/>
+              <a:buNone/>
+            </a:pPr>
+            <a:r>
+              <a:rPr b="0" i="0" lang="en" sz="819" u="none" cap="none" strike="noStrike">
+                <a:solidFill>
+                  <a:srgbClr val="25303B"/>
+                </a:solidFill>
+                <a:latin typeface="Manrope"/>
+                <a:ea typeface="Manrope"/>
+                <a:cs typeface="Manrope"/>
+                <a:sym typeface="Manrope"/>
+              </a:rPr>
+              <a:t>•  Ledger Phase-1 foundation (journal + payouts) live</a:t>
             </a:r>
             <a:endParaRPr b="0" i="0" sz="1400" u="none" cap="none" strike="noStrike">
               <a:solidFill>
@@ -8549,7 +8698,87 @@
                 <a:cs typeface="Manrope"/>
                 <a:sym typeface="Manrope"/>
               </a:rPr>
-              <a:t>›  Wallet-based auto-reconciliation across trips</a:t>
+              <a:t>›  Trip Statement — 3-yr ledger tab in FO App (in build)</a:t>
+            </a:r>
+            <a:endParaRPr b="0" i="0" sz="1400" u="none" cap="none" strike="noStrike">
+              <a:solidFill>
+                <a:srgbClr val="000000"/>
+              </a:solidFill>
+              <a:latin typeface="Arial"/>
+              <a:ea typeface="Arial"/>
+              <a:cs typeface="Arial"/>
+              <a:sym typeface="Arial"/>
+            </a:endParaRPr>
+          </a:p>
+          <a:p>
+            <a:pPr indent="-137160" lvl="0" marL="137160" marR="0" rtl="0" algn="l">
+              <a:lnSpc>
+                <a:spcPct val="102000"/>
+              </a:lnSpc>
+              <a:spcBef>
+                <a:spcPts val="250"/>
+              </a:spcBef>
+              <a:spcAft>
+                <a:spcPts val="0"/>
+              </a:spcAft>
+              <a:buClr>
+                <a:srgbClr val="000000"/>
+              </a:buClr>
+              <a:buSzPts val="818"/>
+              <a:buFont typeface="Arial"/>
+              <a:buNone/>
+            </a:pPr>
+            <a:r>
+              <a:rPr b="0" i="0" lang="en" sz="819" u="none" cap="none" strike="noStrike">
+                <a:solidFill>
+                  <a:schemeClr val="dk1"/>
+                </a:solidFill>
+                <a:latin typeface="Manrope"/>
+                <a:ea typeface="Manrope"/>
+                <a:cs typeface="Manrope"/>
+                <a:sym typeface="Manrope"/>
+              </a:rPr>
+              <a:t>›  TDS rate + self-serve TDS declaration in FO App</a:t>
+            </a:r>
+            <a:endParaRPr b="0" i="0" sz="1400" u="none" cap="none" strike="noStrike">
+              <a:solidFill>
+                <a:srgbClr val="000000"/>
+              </a:solidFill>
+              <a:latin typeface="Arial"/>
+              <a:ea typeface="Arial"/>
+              <a:cs typeface="Arial"/>
+              <a:sym typeface="Arial"/>
+            </a:endParaRPr>
+          </a:p>
+          <a:p>
+            <a:pPr indent="-137160" lvl="0" marL="137160" marR="0" rtl="0" algn="l">
+              <a:lnSpc>
+                <a:spcPct val="102000"/>
+              </a:lnSpc>
+              <a:spcBef>
+                <a:spcPts val="250"/>
+              </a:spcBef>
+              <a:spcAft>
+                <a:spcPts val="0"/>
+              </a:spcAft>
+              <a:buClr>
+                <a:srgbClr val="000000"/>
+              </a:buClr>
+              <a:buSzPts val="818"/>
+              <a:buFont typeface="Arial"/>
+              <a:buNone/>
+            </a:pPr>
+            <a:r>
+              <a:rPr b="0" i="0" lang="en" sz="819" u="none" cap="none" strike="noStrike">
+                <a:solidFill>
+                  <a:schemeClr val="dk1"/>
+                </a:solidFill>
+                <a:latin typeface="Manrope"/>
+                <a:ea typeface="Manrope"/>
+                <a:cs typeface="Manrope"/>
+                <a:sym typeface="Manrope"/>
+              </a:rPr>
+              <a:t>›  LSP exposure limit; wallet auto-reconciliation</a:t>
             </a:r>
             <a:endParaRPr b="0" i="0" sz="1400" u="none" cap="none" strike="noStrike">
               <a:solidFill>

</xml_diff>

<commit_message>
July deck: progress thru Jul, Next Focus Aug-Sept, add roadmap detail slide
- Slide 1 headers: PROGRESS (thru Jul'26), NEXT FOCUS (Aug-Sept); trend
  stays May-Jun-Jul
- Rewrite Next-Focus bullets per row from the new Aug-Sept roadmap table
  (Finance/Ledger, Fulfilment, FO App, Ops rows); Inventory row unchanged
  (not covered by new table)
- Add slide 2: full Aug-Sept roadmap detail (15 initiatives across 7
  buckets: Finance & Ledger, Risk/Fraud/Exposure, FO App Transparency,
  Fulfilment & Demand Intelligence, POD Collection & Audit, LSP
  Experience, Support & Ops) with task + measurable outcome per item

Co-Authored-By: Claude Sonnet 5 <noreply@anthropic.com>
Claude-Session: https://claude.ai/code/session_01HTHNkMyy3hCJ7Wqf5x3kDZ
</commit_message>
<xml_diff>
--- a/board_review_q2_2026/july_update/TML_July_Update.pptx
+++ b/board_review_q2_2026/july_update/TML_July_Update.pptx
@@ -9,6 +9,7 @@
   </p:notesMasterIdLst>
   <p:sldIdLst>
     <p:sldId id="256" r:id="rId6"/>
+    <p:sldId id="257" r:id="rId9"/>
   </p:sldIdLst>
   <p:sldSz cy="5143500" cx="9144000"/>
   <p:notesSz cx="6858000" cy="9144000"/>
@@ -6482,7 +6483,7 @@
                 <a:cs typeface="Manrope"/>
                 <a:sym typeface="Manrope"/>
               </a:rPr>
-              <a:t>JUN–JUL PROGRESS</a:t>
+              <a:t>PROGRESS  (thru Jul'26)</a:t>
             </a:r>
             <a:endParaRPr b="0" i="0" sz="1400" u="none" cap="none" strike="noStrike">
               <a:solidFill>
@@ -6618,19 +6619,7 @@
                 <a:cs typeface="Manrope"/>
                 <a:sym typeface="Manrope"/>
               </a:rPr>
-              <a:t>NEXT</a:t>
-            </a:r>
-            <a:r>
-              <a:rPr b="1" lang="en" sz="950">
-                <a:solidFill>
-                  <a:schemeClr val="dk1"/>
-                </a:solidFill>
-                <a:latin typeface="Manrope"/>
-                <a:ea typeface="Manrope"/>
-                <a:cs typeface="Manrope"/>
-                <a:sym typeface="Manrope"/>
-              </a:rPr>
-              <a:t> Focus</a:t>
+              <a:t>NEXT FOCUS  (Aug–Sept)</a:t>
             </a:r>
             <a:endParaRPr b="0" i="0" sz="1400" u="none" cap="none" strike="noStrike">
               <a:solidFill>
@@ -6975,7 +6964,7 @@
                 <a:cs typeface="Manrope"/>
                 <a:sym typeface="Manrope"/>
               </a:rPr>
-              <a:t>›  Drive towards 500 DAU</a:t>
+              <a:t>›  Trip Statement — 3-yr ledger tab in FO App</a:t>
             </a:r>
             <a:endParaRPr b="0" i="0" sz="1400" u="none" cap="none" strike="noStrike">
               <a:solidFill>
@@ -7015,7 +7004,7 @@
                 <a:cs typeface="Manrope"/>
                 <a:sym typeface="Manrope"/>
               </a:rPr>
-              <a:t>›  Reach PSA directly for placement (in build)</a:t>
+              <a:t>›  TDS rate visibility + self-serve declaration</a:t>
             </a:r>
             <a:endParaRPr b="0" i="0" sz="1400" u="none" cap="none" strike="noStrike">
               <a:solidFill>
@@ -7055,7 +7044,7 @@
                 <a:cs typeface="Manrope"/>
                 <a:sym typeface="Manrope"/>
               </a:rPr>
-              <a:t>›  Trip payment statement + in-app advance</a:t>
+              <a:t>›  Ticketing for FOs not on app (WhatsApp/IVR)</a:t>
             </a:r>
             <a:endParaRPr b="0" i="0" sz="1400" u="none" cap="none" strike="noStrike">
               <a:solidFill>
@@ -7400,7 +7389,7 @@
                 <a:cs typeface="Manrope"/>
                 <a:sym typeface="Manrope"/>
               </a:rPr>
-              <a:t>›  Agent → lane auto-assignment (shipped)</a:t>
+              <a:t>›  Auto CRM alerts — bids / matches / approvals</a:t>
             </a:r>
             <a:endParaRPr b="0" i="0" sz="819" u="none" cap="none" strike="noStrike">
               <a:solidFill>
@@ -7440,7 +7429,7 @@
                 <a:cs typeface="Manrope"/>
                 <a:sym typeface="Manrope"/>
               </a:rPr>
-              <a:t>›  Prioritise demand list; Demand-Bot context (in build)</a:t>
+              <a:t>›  Sort demand by Demand Actionability Score</a:t>
             </a:r>
             <a:endParaRPr b="0" i="0" sz="819" u="none" cap="none" strike="noStrike">
               <a:solidFill>
@@ -7480,7 +7469,7 @@
                 <a:cs typeface="Manrope"/>
                 <a:sym typeface="Manrope"/>
               </a:rPr>
-              <a:t>›  Push network-lane fulfilment → 20%</a:t>
+              <a:t>›  Agentic AI calling for fulfilment agents</a:t>
             </a:r>
             <a:endParaRPr b="0" i="0" sz="819" u="none" cap="none" strike="noStrike">
               <a:solidFill>
@@ -8275,7 +8264,7 @@
                 <a:cs typeface="Manrope"/>
                 <a:sym typeface="Manrope"/>
               </a:rPr>
-              <a:t>›  Automate SIM-consent, pre-transit (in build)</a:t>
+              <a:t>›  Runner App — POD collection + OCR audit</a:t>
             </a:r>
             <a:endParaRPr b="0" i="0" sz="1400" u="none" cap="none" strike="noStrike">
               <a:solidFill>
@@ -8315,7 +8304,7 @@
                 <a:cs typeface="Manrope"/>
                 <a:sym typeface="Manrope"/>
               </a:rPr>
-              <a:t>›  FO doc collection via App; transit-delay detection</a:t>
+              <a:t>›  LSP App — self-serve trip/tracking/POD + tickets</a:t>
             </a:r>
             <a:endParaRPr b="0" i="0" sz="1400" u="none" cap="none" strike="noStrike">
               <a:solidFill>
@@ -8355,7 +8344,7 @@
                 <a:cs typeface="Manrope"/>
                 <a:sym typeface="Manrope"/>
               </a:rPr>
-              <a:t>›  Auto-create Pylon tickets from LSP WhatsApp (POC)</a:t>
+              <a:t>›  Automate compliance document generation</a:t>
             </a:r>
             <a:endParaRPr b="0" i="0" sz="1400" u="none" cap="none" strike="noStrike">
               <a:solidFill>
@@ -8698,7 +8687,7 @@
                 <a:cs typeface="Manrope"/>
                 <a:sym typeface="Manrope"/>
               </a:rPr>
-              <a:t>›  Trip Statement — 3-yr ledger tab in FO App (in build)</a:t>
+              <a:t>›  Auto-calc &amp; reverse TDS; advance-pay auto-release (60%)</a:t>
             </a:r>
             <a:endParaRPr b="0" i="0" sz="1400" u="none" cap="none" strike="noStrike">
               <a:solidFill>
@@ -8738,7 +8727,7 @@
                 <a:cs typeface="Manrope"/>
                 <a:sym typeface="Manrope"/>
               </a:rPr>
-              <a:t>›  TDS rate + self-serve TDS declaration in FO App</a:t>
+              <a:t>›  Payment fraud checks + LSP exposure limits</a:t>
             </a:r>
             <a:endParaRPr b="0" i="0" sz="1400" u="none" cap="none" strike="noStrike">
               <a:solidFill>
@@ -8778,7 +8767,7 @@
                 <a:cs typeface="Manrope"/>
                 <a:sym typeface="Manrope"/>
               </a:rPr>
-              <a:t>›  LSP exposure limit; wallet auto-reconciliation</a:t>
+              <a:t>›  Self-serve balance payment for FOs</a:t>
             </a:r>
             <a:endParaRPr b="0" i="0" sz="1400" u="none" cap="none" strike="noStrike">
               <a:solidFill>
@@ -9021,6 +9010,1892 @@
           </a:prstGeom>
         </p:spPr>
       </p:pic>
+    </p:spTree>
+  </p:cSld>
+  <p:clrMapOvr>
+    <a:masterClrMapping/>
+  </p:clrMapOvr>
+</p:sld>
+</file>
+
+<file path=ppt/slides/slide2.xml><?xml version="1.0" encoding="utf-8"?>
+<p:sld xmlns:a="http://schemas.openxmlformats.org/drawingml/2006/main" xmlns:p="http://schemas.openxmlformats.org/presentationml/2006/main" xmlns:r="http://schemas.openxmlformats.org/officeDocument/2006/relationships">
+  <p:cSld>
+    <p:spTree>
+      <p:nvGrpSpPr>
+        <p:cNvPr id="1" name=""/>
+        <p:cNvGrpSpPr/>
+        <p:nvPr/>
+      </p:nvGrpSpPr>
+      <p:grpSpPr/>
+      <p:sp>
+        <p:nvSpPr>
+          <p:cNvPr id="2" name="TextBox 1"/>
+          <p:cNvSpPr txBox="1"/>
+          <p:nvPr/>
+        </p:nvSpPr>
+        <p:spPr>
+          <a:xfrm>
+            <a:off x="228600" y="155000"/>
+            <a:ext cx="7900000" cy="300000"/>
+          </a:xfrm>
+          <a:prstGeom prst="rect">
+            <a:avLst/>
+          </a:prstGeom>
+          <a:noFill/>
+        </p:spPr>
+        <p:txBody>
+          <a:bodyPr wrap="square" anchor="t" lIns="0" rIns="0" tIns="0" bIns="0">
+            <a:spAutoFit/>
+          </a:bodyPr>
+          <a:lstStyle/>
+          <a:p>
+            <a:pPr algn="l">
+              <a:lnSpc>
+                <a:spcPct val="100000"/>
+              </a:lnSpc>
+              <a:spcBef>
+                <a:spcPts val="0"/>
+              </a:spcBef>
+              <a:spcAft>
+                <a:spcPts val="100"/>
+              </a:spcAft>
+            </a:pPr>
+            <a:r>
+              <a:rPr sz="1500" b="1" i="0">
+                <a:solidFill>
+                  <a:srgbClr val="1F3763"/>
+                </a:solidFill>
+                <a:latin typeface="Manrope"/>
+                <a:cs typeface="Manrope"/>
+              </a:rPr>
+              <a:t>Next Focus — Aug–Sept'26 Roadmap</a:t>
+            </a:r>
+          </a:p>
+        </p:txBody>
+      </p:sp>
+      <p:sp>
+        <p:nvSpPr>
+          <p:cNvPr id="3" name="TextBox 2"/>
+          <p:cNvSpPr txBox="1"/>
+          <p:nvPr/>
+        </p:nvSpPr>
+        <p:spPr>
+          <a:xfrm>
+            <a:off x="228600" y="458000"/>
+            <a:ext cx="8680000" cy="220000"/>
+          </a:xfrm>
+          <a:prstGeom prst="rect">
+            <a:avLst/>
+          </a:prstGeom>
+          <a:noFill/>
+        </p:spPr>
+        <p:txBody>
+          <a:bodyPr wrap="square" anchor="t" lIns="0" rIns="0" tIns="0" bIns="0">
+            <a:spAutoFit/>
+          </a:bodyPr>
+          <a:lstStyle/>
+          <a:p>
+            <a:pPr algn="l">
+              <a:lnSpc>
+                <a:spcPct val="100000"/>
+              </a:lnSpc>
+              <a:spcBef>
+                <a:spcPts val="0"/>
+              </a:spcBef>
+              <a:spcAft>
+                <a:spcPts val="200"/>
+              </a:spcAft>
+            </a:pPr>
+            <a:r>
+              <a:rPr sz="900" b="0" i="1">
+                <a:solidFill>
+                  <a:srgbClr val="6B7480"/>
+                </a:solidFill>
+                <a:latin typeface="Manrope"/>
+                <a:cs typeface="Manrope"/>
+              </a:rPr>
+              <a:t>15 initiatives across Finance/Ledger, Risk, Fulfilment, FO/LSP Experience &amp; Ops — bucketed with measurable outcomes</a:t>
+            </a:r>
+          </a:p>
+        </p:txBody>
+      </p:sp>
+      <p:cxnSp>
+        <p:nvCxnSpPr>
+          <p:cNvPr id="4" name="Connector 3"/>
+          <p:cNvCxnSpPr/>
+          <p:nvPr/>
+        </p:nvCxnSpPr>
+        <p:spPr>
+          <a:xfrm>
+            <a:off x="242398" y="662000"/>
+            <a:ext cx="8616600" cy="0"/>
+          </a:xfrm>
+          <a:prstGeom prst="line">
+            <a:avLst/>
+          </a:prstGeom>
+          <a:ln w="12700">
+            <a:solidFill>
+              <a:srgbClr val="D5DAE1"/>
+            </a:solidFill>
+          </a:ln>
+          <a:effectLst/>
+        </p:spPr>
+        <p:style>
+          <a:lnRef idx="2">
+            <a:schemeClr val="accent1"/>
+          </a:lnRef>
+          <a:fillRef idx="0">
+            <a:schemeClr val="accent1"/>
+          </a:fillRef>
+          <a:effectRef idx="1">
+            <a:schemeClr val="accent1"/>
+          </a:effectRef>
+          <a:fontRef idx="minor">
+            <a:schemeClr val="tx1"/>
+          </a:fontRef>
+        </p:style>
+      </p:cxnSp>
+      <p:pic>
+        <p:nvPicPr>
+          <p:cNvPr id="5" name="Picture 4" descr="image.png"/>
+          <p:cNvPicPr>
+            <a:picLocks noChangeAspect="1"/>
+          </p:cNvPicPr>
+          <p:nvPr/>
+        </p:nvPicPr>
+        <p:blipFill>
+          <a:blip r:embed="rId2"/>
+          <a:stretch>
+            <a:fillRect/>
+          </a:stretch>
+        </p:blipFill>
+        <p:spPr>
+          <a:xfrm>
+            <a:off x="8247328" y="65382"/>
+            <a:ext cx="821475" cy="355725"/>
+          </a:xfrm>
+          <a:prstGeom prst="rect">
+            <a:avLst/>
+          </a:prstGeom>
+        </p:spPr>
+      </p:pic>
+      <p:sp>
+        <p:nvSpPr>
+          <p:cNvPr id="6" name="TextBox 5"/>
+          <p:cNvSpPr txBox="1"/>
+          <p:nvPr/>
+        </p:nvSpPr>
+        <p:spPr>
+          <a:xfrm>
+            <a:off x="7182075" y="4905000"/>
+            <a:ext cx="1652700" cy="180000"/>
+          </a:xfrm>
+          <a:prstGeom prst="rect">
+            <a:avLst/>
+          </a:prstGeom>
+          <a:noFill/>
+        </p:spPr>
+        <p:txBody>
+          <a:bodyPr wrap="square" anchor="t" lIns="0" rIns="0" tIns="0" bIns="0">
+            <a:spAutoFit/>
+          </a:bodyPr>
+          <a:lstStyle/>
+          <a:p>
+            <a:pPr algn="r">
+              <a:lnSpc>
+                <a:spcPct val="100000"/>
+              </a:lnSpc>
+              <a:spcBef>
+                <a:spcPts val="0"/>
+              </a:spcBef>
+              <a:spcAft>
+                <a:spcPts val="200"/>
+              </a:spcAft>
+            </a:pPr>
+            <a:r>
+              <a:rPr sz="800" b="0" i="0">
+                <a:solidFill>
+                  <a:srgbClr val="B8BEC6"/>
+                </a:solidFill>
+                <a:latin typeface="Manrope"/>
+                <a:cs typeface="Manrope"/>
+              </a:rPr>
+              <a:t>@FreightTiger confidential</a:t>
+            </a:r>
+          </a:p>
+        </p:txBody>
+      </p:sp>
+      <p:sp>
+        <p:nvSpPr>
+          <p:cNvPr id="7" name="Rounded Rectangle 6"/>
+          <p:cNvSpPr/>
+          <p:nvPr/>
+        </p:nvSpPr>
+        <p:spPr>
+          <a:xfrm>
+            <a:off x="228600" y="980000"/>
+            <a:ext cx="2864933" cy="3320000"/>
+          </a:xfrm>
+          <a:prstGeom prst="roundRect">
+            <a:avLst>
+              <a:gd name="adj" fmla="val 9000"/>
+            </a:avLst>
+          </a:prstGeom>
+          <a:solidFill>
+            <a:srgbClr val="F7F8FA"/>
+          </a:solidFill>
+          <a:ln w="6350">
+            <a:solidFill>
+              <a:srgbClr val="D5DAE1"/>
+            </a:solidFill>
+          </a:ln>
+          <a:effectLst/>
+        </p:spPr>
+        <p:style>
+          <a:lnRef idx="1">
+            <a:schemeClr val="accent1"/>
+          </a:lnRef>
+          <a:fillRef idx="3">
+            <a:schemeClr val="accent1"/>
+          </a:fillRef>
+          <a:effectRef idx="2">
+            <a:schemeClr val="accent1"/>
+          </a:effectRef>
+          <a:fontRef idx="minor">
+            <a:schemeClr val="lt1"/>
+          </a:fontRef>
+        </p:style>
+        <p:txBody>
+          <a:bodyPr rtlCol="0" anchor="ctr"/>
+          <a:lstStyle/>
+          <a:p>
+            <a:pPr algn="ctr"/>
+          </a:p>
+        </p:txBody>
+      </p:sp>
+      <p:sp>
+        <p:nvSpPr>
+          <p:cNvPr id="8" name="Rounded Rectangle 7"/>
+          <p:cNvSpPr/>
+          <p:nvPr/>
+        </p:nvSpPr>
+        <p:spPr>
+          <a:xfrm>
+            <a:off x="246600" y="1002000"/>
+            <a:ext cx="36000" cy="3276000"/>
+          </a:xfrm>
+          <a:prstGeom prst="roundRect">
+            <a:avLst>
+              <a:gd name="adj" fmla="val 40000"/>
+            </a:avLst>
+          </a:prstGeom>
+          <a:solidFill>
+            <a:srgbClr val="1F3763"/>
+          </a:solidFill>
+          <a:ln>
+            <a:noFill/>
+          </a:ln>
+          <a:effectLst/>
+        </p:spPr>
+        <p:style>
+          <a:lnRef idx="1">
+            <a:schemeClr val="accent1"/>
+          </a:lnRef>
+          <a:fillRef idx="3">
+            <a:schemeClr val="accent1"/>
+          </a:fillRef>
+          <a:effectRef idx="2">
+            <a:schemeClr val="accent1"/>
+          </a:effectRef>
+          <a:fontRef idx="minor">
+            <a:schemeClr val="lt1"/>
+          </a:fontRef>
+        </p:style>
+        <p:txBody>
+          <a:bodyPr rtlCol="0" anchor="ctr"/>
+          <a:lstStyle/>
+          <a:p>
+            <a:pPr algn="ctr"/>
+          </a:p>
+        </p:txBody>
+      </p:sp>
+      <p:sp>
+        <p:nvSpPr>
+          <p:cNvPr id="9" name="TextBox 8"/>
+          <p:cNvSpPr txBox="1"/>
+          <p:nvPr/>
+        </p:nvSpPr>
+        <p:spPr>
+          <a:xfrm>
+            <a:off x="308600" y="998000"/>
+            <a:ext cx="2744933" cy="3288000"/>
+          </a:xfrm>
+          <a:prstGeom prst="rect">
+            <a:avLst/>
+          </a:prstGeom>
+          <a:noFill/>
+        </p:spPr>
+        <p:txBody>
+          <a:bodyPr wrap="square" anchor="t" lIns="0" rIns="0" tIns="0" bIns="0">
+            <a:spAutoFit/>
+          </a:bodyPr>
+          <a:lstStyle/>
+          <a:p>
+            <a:pPr algn="l">
+              <a:lnSpc>
+                <a:spcPct val="100000"/>
+              </a:lnSpc>
+              <a:spcBef>
+                <a:spcPts val="0"/>
+              </a:spcBef>
+              <a:spcAft>
+                <a:spcPts val="500"/>
+              </a:spcAft>
+            </a:pPr>
+            <a:r>
+              <a:rPr sz="950" b="1" i="0">
+                <a:solidFill>
+                  <a:srgbClr val="1F3763"/>
+                </a:solidFill>
+                <a:latin typeface="Manrope"/>
+                <a:cs typeface="Manrope"/>
+              </a:rPr>
+              <a:t>Finance Automation &amp; Ledger</a:t>
+            </a:r>
+          </a:p>
+          <a:p>
+            <a:pPr algn="l">
+              <a:lnSpc>
+                <a:spcPct val="105000"/>
+              </a:lnSpc>
+              <a:spcBef>
+                <a:spcPts val="0"/>
+              </a:spcBef>
+              <a:spcAft>
+                <a:spcPts val="100"/>
+              </a:spcAft>
+            </a:pPr>
+            <a:r>
+              <a:rPr sz="760" b="1" i="0">
+                <a:solidFill>
+                  <a:srgbClr val="25303B"/>
+                </a:solidFill>
+                <a:latin typeface="Manrope"/>
+                <a:cs typeface="Manrope"/>
+              </a:rPr>
+              <a:t>Ledger Automation in CRM  </a:t>
+            </a:r>
+          </a:p>
+          <a:p>
+            <a:pPr algn="l">
+              <a:lnSpc>
+                <a:spcPct val="105000"/>
+              </a:lnSpc>
+              <a:spcBef>
+                <a:spcPts val="0"/>
+              </a:spcBef>
+              <a:spcAft>
+                <a:spcPts val="600"/>
+              </a:spcAft>
+            </a:pPr>
+            <a:r>
+              <a:rPr sz="720" b="0" i="1">
+                <a:solidFill>
+                  <a:srgbClr val="6B7480"/>
+                </a:solidFill>
+                <a:latin typeface="Manrope"/>
+                <a:cs typeface="Manrope"/>
+              </a:rPr>
+              <a:t>100% trips carry immutable payment record; overpayment auto-settled to wallets</a:t>
+            </a:r>
+          </a:p>
+          <a:p>
+            <a:pPr algn="l">
+              <a:lnSpc>
+                <a:spcPct val="105000"/>
+              </a:lnSpc>
+              <a:spcBef>
+                <a:spcPts val="0"/>
+              </a:spcBef>
+              <a:spcAft>
+                <a:spcPts val="100"/>
+              </a:spcAft>
+            </a:pPr>
+            <a:r>
+              <a:rPr sz="760" b="1" i="0">
+                <a:solidFill>
+                  <a:srgbClr val="25303B"/>
+                </a:solidFill>
+                <a:latin typeface="Manrope"/>
+                <a:cs typeface="Manrope"/>
+              </a:rPr>
+              <a:t>Auto-calculate TDS  </a:t>
+            </a:r>
+          </a:p>
+          <a:p>
+            <a:pPr algn="l">
+              <a:lnSpc>
+                <a:spcPct val="105000"/>
+              </a:lnSpc>
+              <a:spcBef>
+                <a:spcPts val="0"/>
+              </a:spcBef>
+              <a:spcAft>
+                <a:spcPts val="600"/>
+              </a:spcAft>
+            </a:pPr>
+            <a:r>
+              <a:rPr sz="720" b="0" i="1">
+                <a:solidFill>
+                  <a:srgbClr val="6B7480"/>
+                </a:solidFill>
+                <a:latin typeface="Manrope"/>
+                <a:cs typeface="Manrope"/>
+              </a:rPr>
+              <a:t>100% trips system-calculated; ~0 error rate; 60 hrs/mo ops saved</a:t>
+            </a:r>
+          </a:p>
+          <a:p>
+            <a:pPr algn="l">
+              <a:lnSpc>
+                <a:spcPct val="105000"/>
+              </a:lnSpc>
+              <a:spcBef>
+                <a:spcPts val="0"/>
+              </a:spcBef>
+              <a:spcAft>
+                <a:spcPts val="100"/>
+              </a:spcAft>
+            </a:pPr>
+            <a:r>
+              <a:rPr sz="760" b="1" i="0">
+                <a:solidFill>
+                  <a:srgbClr val="25303B"/>
+                </a:solidFill>
+                <a:latin typeface="Manrope"/>
+                <a:cs typeface="Manrope"/>
+              </a:rPr>
+              <a:t>Automated Advance Payment (Gold/Silver FOs)  </a:t>
+            </a:r>
+          </a:p>
+          <a:p>
+            <a:pPr algn="l">
+              <a:lnSpc>
+                <a:spcPct val="105000"/>
+              </a:lnSpc>
+              <a:spcBef>
+                <a:spcPts val="0"/>
+              </a:spcBef>
+              <a:spcAft>
+                <a:spcPts val="600"/>
+              </a:spcAft>
+            </a:pPr>
+            <a:r>
+              <a:rPr sz="720" b="0" i="1">
+                <a:solidFill>
+                  <a:srgbClr val="6B7480"/>
+                </a:solidFill>
+                <a:latin typeface="Manrope"/>
+                <a:cs typeface="Manrope"/>
+              </a:rPr>
+              <a:t>60% auto-released; disbursal TAT → 2 hrs</a:t>
+            </a:r>
+          </a:p>
+          <a:p>
+            <a:pPr algn="l">
+              <a:lnSpc>
+                <a:spcPct val="105000"/>
+              </a:lnSpc>
+              <a:spcBef>
+                <a:spcPts val="0"/>
+              </a:spcBef>
+              <a:spcAft>
+                <a:spcPts val="100"/>
+              </a:spcAft>
+            </a:pPr>
+            <a:r>
+              <a:rPr sz="760" b="1" i="0">
+                <a:solidFill>
+                  <a:srgbClr val="25303B"/>
+                </a:solidFill>
+                <a:latin typeface="Manrope"/>
+                <a:cs typeface="Manrope"/>
+              </a:rPr>
+              <a:t>Automate compliance document generation  </a:t>
+            </a:r>
+          </a:p>
+          <a:p>
+            <a:pPr algn="l">
+              <a:lnSpc>
+                <a:spcPct val="105000"/>
+              </a:lnSpc>
+              <a:spcBef>
+                <a:spcPts val="0"/>
+              </a:spcBef>
+              <a:spcAft>
+                <a:spcPts val="600"/>
+              </a:spcAft>
+            </a:pPr>
+            <a:r>
+              <a:rPr sz="720" b="0" i="1">
+                <a:solidFill>
+                  <a:srgbClr val="6B7480"/>
+                </a:solidFill>
+                <a:latin typeface="Manrope"/>
+                <a:cs typeface="Manrope"/>
+              </a:rPr>
+              <a:t>100% auto-generated; 60 hrs/mo saved</a:t>
+            </a:r>
+          </a:p>
+          <a:p>
+            <a:pPr algn="l">
+              <a:lnSpc>
+                <a:spcPct val="105000"/>
+              </a:lnSpc>
+              <a:spcBef>
+                <a:spcPts val="0"/>
+              </a:spcBef>
+              <a:spcAft>
+                <a:spcPts val="100"/>
+              </a:spcAft>
+            </a:pPr>
+            <a:r>
+              <a:rPr sz="760" b="1" i="0">
+                <a:solidFill>
+                  <a:srgbClr val="25303B"/>
+                </a:solidFill>
+                <a:latin typeface="Manrope"/>
+                <a:cs typeface="Manrope"/>
+              </a:rPr>
+              <a:t>Balance payment automation  </a:t>
+            </a:r>
+          </a:p>
+          <a:p>
+            <a:pPr algn="l">
+              <a:lnSpc>
+                <a:spcPct val="105000"/>
+              </a:lnSpc>
+              <a:spcBef>
+                <a:spcPts val="0"/>
+              </a:spcBef>
+              <a:spcAft>
+                <a:spcPts val="600"/>
+              </a:spcAft>
+            </a:pPr>
+            <a:r>
+              <a:rPr sz="720" b="0" i="1">
+                <a:solidFill>
+                  <a:srgbClr val="6B7480"/>
+                </a:solidFill>
+                <a:latin typeface="Manrope"/>
+                <a:cs typeface="Manrope"/>
+              </a:rPr>
+              <a:t>60% self-initiated by FO; fewer ops touchpoints</a:t>
+            </a:r>
+          </a:p>
+        </p:txBody>
+      </p:sp>
+      <p:sp>
+        <p:nvSpPr>
+          <p:cNvPr id="10" name="Rounded Rectangle 9"/>
+          <p:cNvSpPr/>
+          <p:nvPr/>
+        </p:nvSpPr>
+        <p:spPr>
+          <a:xfrm>
+            <a:off x="3139533" y="980000"/>
+            <a:ext cx="2864933" cy="1956000"/>
+          </a:xfrm>
+          <a:prstGeom prst="roundRect">
+            <a:avLst>
+              <a:gd name="adj" fmla="val 9000"/>
+            </a:avLst>
+          </a:prstGeom>
+          <a:solidFill>
+            <a:srgbClr val="F7F8FA"/>
+          </a:solidFill>
+          <a:ln w="6350">
+            <a:solidFill>
+              <a:srgbClr val="D5DAE1"/>
+            </a:solidFill>
+          </a:ln>
+          <a:effectLst/>
+        </p:spPr>
+        <p:style>
+          <a:lnRef idx="1">
+            <a:schemeClr val="accent1"/>
+          </a:lnRef>
+          <a:fillRef idx="3">
+            <a:schemeClr val="accent1"/>
+          </a:fillRef>
+          <a:effectRef idx="2">
+            <a:schemeClr val="accent1"/>
+          </a:effectRef>
+          <a:fontRef idx="minor">
+            <a:schemeClr val="lt1"/>
+          </a:fontRef>
+        </p:style>
+        <p:txBody>
+          <a:bodyPr rtlCol="0" anchor="ctr"/>
+          <a:lstStyle/>
+          <a:p>
+            <a:pPr algn="ctr"/>
+          </a:p>
+        </p:txBody>
+      </p:sp>
+      <p:sp>
+        <p:nvSpPr>
+          <p:cNvPr id="11" name="Rounded Rectangle 10"/>
+          <p:cNvSpPr/>
+          <p:nvPr/>
+        </p:nvSpPr>
+        <p:spPr>
+          <a:xfrm>
+            <a:off x="3157533" y="1002000"/>
+            <a:ext cx="36000" cy="1912000"/>
+          </a:xfrm>
+          <a:prstGeom prst="roundRect">
+            <a:avLst>
+              <a:gd name="adj" fmla="val 40000"/>
+            </a:avLst>
+          </a:prstGeom>
+          <a:solidFill>
+            <a:srgbClr val="26815C"/>
+          </a:solidFill>
+          <a:ln>
+            <a:noFill/>
+          </a:ln>
+          <a:effectLst/>
+        </p:spPr>
+        <p:style>
+          <a:lnRef idx="1">
+            <a:schemeClr val="accent1"/>
+          </a:lnRef>
+          <a:fillRef idx="3">
+            <a:schemeClr val="accent1"/>
+          </a:fillRef>
+          <a:effectRef idx="2">
+            <a:schemeClr val="accent1"/>
+          </a:effectRef>
+          <a:fontRef idx="minor">
+            <a:schemeClr val="lt1"/>
+          </a:fontRef>
+        </p:style>
+        <p:txBody>
+          <a:bodyPr rtlCol="0" anchor="ctr"/>
+          <a:lstStyle/>
+          <a:p>
+            <a:pPr algn="ctr"/>
+          </a:p>
+        </p:txBody>
+      </p:sp>
+      <p:sp>
+        <p:nvSpPr>
+          <p:cNvPr id="12" name="TextBox 11"/>
+          <p:cNvSpPr txBox="1"/>
+          <p:nvPr/>
+        </p:nvSpPr>
+        <p:spPr>
+          <a:xfrm>
+            <a:off x="3219533" y="998000"/>
+            <a:ext cx="2744933" cy="1924000"/>
+          </a:xfrm>
+          <a:prstGeom prst="rect">
+            <a:avLst/>
+          </a:prstGeom>
+          <a:noFill/>
+        </p:spPr>
+        <p:txBody>
+          <a:bodyPr wrap="square" anchor="t" lIns="0" rIns="0" tIns="0" bIns="0">
+            <a:spAutoFit/>
+          </a:bodyPr>
+          <a:lstStyle/>
+          <a:p>
+            <a:pPr algn="l">
+              <a:lnSpc>
+                <a:spcPct val="100000"/>
+              </a:lnSpc>
+              <a:spcBef>
+                <a:spcPts val="0"/>
+              </a:spcBef>
+              <a:spcAft>
+                <a:spcPts val="500"/>
+              </a:spcAft>
+            </a:pPr>
+            <a:r>
+              <a:rPr sz="950" b="1" i="0">
+                <a:solidFill>
+                  <a:srgbClr val="26815C"/>
+                </a:solidFill>
+                <a:latin typeface="Manrope"/>
+                <a:cs typeface="Manrope"/>
+              </a:rPr>
+              <a:t>Fulfilment &amp; Demand Intelligence</a:t>
+            </a:r>
+          </a:p>
+          <a:p>
+            <a:pPr algn="l">
+              <a:lnSpc>
+                <a:spcPct val="105000"/>
+              </a:lnSpc>
+              <a:spcBef>
+                <a:spcPts val="0"/>
+              </a:spcBef>
+              <a:spcAft>
+                <a:spcPts val="100"/>
+              </a:spcAft>
+            </a:pPr>
+            <a:r>
+              <a:rPr sz="760" b="1" i="0">
+                <a:solidFill>
+                  <a:srgbClr val="25303B"/>
+                </a:solidFill>
+                <a:latin typeface="Manrope"/>
+                <a:cs typeface="Manrope"/>
+              </a:rPr>
+              <a:t>Auto CRM alerts  </a:t>
+            </a:r>
+          </a:p>
+          <a:p>
+            <a:pPr algn="l">
+              <a:lnSpc>
+                <a:spcPct val="105000"/>
+              </a:lnSpc>
+              <a:spcBef>
+                <a:spcPts val="0"/>
+              </a:spcBef>
+              <a:spcAft>
+                <a:spcPts val="600"/>
+              </a:spcAft>
+            </a:pPr>
+            <a:r>
+              <a:rPr sz="720" b="0" i="1">
+                <a:solidFill>
+                  <a:srgbClr val="6B7480"/>
+                </a:solidFill>
+                <a:latin typeface="Manrope"/>
+                <a:cs typeface="Manrope"/>
+              </a:rPr>
+              <a:t>bids received / inventory matched / approval assigned — faster time-to-action</a:t>
+            </a:r>
+          </a:p>
+          <a:p>
+            <a:pPr algn="l">
+              <a:lnSpc>
+                <a:spcPct val="105000"/>
+              </a:lnSpc>
+              <a:spcBef>
+                <a:spcPts val="0"/>
+              </a:spcBef>
+              <a:spcAft>
+                <a:spcPts val="100"/>
+              </a:spcAft>
+            </a:pPr>
+            <a:r>
+              <a:rPr sz="760" b="1" i="0">
+                <a:solidFill>
+                  <a:srgbClr val="25303B"/>
+                </a:solidFill>
+                <a:latin typeface="Manrope"/>
+                <a:cs typeface="Manrope"/>
+              </a:rPr>
+              <a:t>Sort demand by Demand Actionability Score  </a:t>
+            </a:r>
+          </a:p>
+          <a:p>
+            <a:pPr algn="l">
+              <a:lnSpc>
+                <a:spcPct val="105000"/>
+              </a:lnSpc>
+              <a:spcBef>
+                <a:spcPts val="0"/>
+              </a:spcBef>
+              <a:spcAft>
+                <a:spcPts val="600"/>
+              </a:spcAft>
+            </a:pPr>
+            <a:r>
+              <a:rPr sz="720" b="0" i="1">
+                <a:solidFill>
+                  <a:srgbClr val="6B7480"/>
+                </a:solidFill>
+                <a:latin typeface="Manrope"/>
+                <a:cs typeface="Manrope"/>
+              </a:rPr>
+              <a:t>more agent time on placeable loads; faster placement</a:t>
+            </a:r>
+          </a:p>
+          <a:p>
+            <a:pPr algn="l">
+              <a:lnSpc>
+                <a:spcPct val="105000"/>
+              </a:lnSpc>
+              <a:spcBef>
+                <a:spcPts val="0"/>
+              </a:spcBef>
+              <a:spcAft>
+                <a:spcPts val="100"/>
+              </a:spcAft>
+            </a:pPr>
+            <a:r>
+              <a:rPr sz="760" b="1" i="0">
+                <a:solidFill>
+                  <a:srgbClr val="25303B"/>
+                </a:solidFill>
+                <a:latin typeface="Manrope"/>
+                <a:cs typeface="Manrope"/>
+              </a:rPr>
+              <a:t>Agentic AI calling for fulfilment agents  </a:t>
+            </a:r>
+          </a:p>
+          <a:p>
+            <a:pPr algn="l">
+              <a:lnSpc>
+                <a:spcPct val="105000"/>
+              </a:lnSpc>
+              <a:spcBef>
+                <a:spcPts val="0"/>
+              </a:spcBef>
+              <a:spcAft>
+                <a:spcPts val="600"/>
+              </a:spcAft>
+            </a:pPr>
+            <a:r>
+              <a:rPr sz="720" b="0" i="1">
+                <a:solidFill>
+                  <a:srgbClr val="6B7480"/>
+                </a:solidFill>
+                <a:latin typeface="Manrope"/>
+                <a:cs typeface="Manrope"/>
+              </a:rPr>
+              <a:t>calls automated at scale; cost/call ↓; conversion ↑</a:t>
+            </a:r>
+          </a:p>
+        </p:txBody>
+      </p:sp>
+      <p:sp>
+        <p:nvSpPr>
+          <p:cNvPr id="13" name="Rounded Rectangle 12"/>
+          <p:cNvSpPr/>
+          <p:nvPr/>
+        </p:nvSpPr>
+        <p:spPr>
+          <a:xfrm>
+            <a:off x="3139533" y="2996000"/>
+            <a:ext cx="2864933" cy="1304000"/>
+          </a:xfrm>
+          <a:prstGeom prst="roundRect">
+            <a:avLst>
+              <a:gd name="adj" fmla="val 9000"/>
+            </a:avLst>
+          </a:prstGeom>
+          <a:solidFill>
+            <a:srgbClr val="F7F8FA"/>
+          </a:solidFill>
+          <a:ln w="6350">
+            <a:solidFill>
+              <a:srgbClr val="D5DAE1"/>
+            </a:solidFill>
+          </a:ln>
+          <a:effectLst/>
+        </p:spPr>
+        <p:style>
+          <a:lnRef idx="1">
+            <a:schemeClr val="accent1"/>
+          </a:lnRef>
+          <a:fillRef idx="3">
+            <a:schemeClr val="accent1"/>
+          </a:fillRef>
+          <a:effectRef idx="2">
+            <a:schemeClr val="accent1"/>
+          </a:effectRef>
+          <a:fontRef idx="minor">
+            <a:schemeClr val="lt1"/>
+          </a:fontRef>
+        </p:style>
+        <p:txBody>
+          <a:bodyPr rtlCol="0" anchor="ctr"/>
+          <a:lstStyle/>
+          <a:p>
+            <a:pPr algn="ctr"/>
+          </a:p>
+        </p:txBody>
+      </p:sp>
+      <p:sp>
+        <p:nvSpPr>
+          <p:cNvPr id="14" name="Rounded Rectangle 13"/>
+          <p:cNvSpPr/>
+          <p:nvPr/>
+        </p:nvSpPr>
+        <p:spPr>
+          <a:xfrm>
+            <a:off x="3157533" y="3018000"/>
+            <a:ext cx="36000" cy="1260000"/>
+          </a:xfrm>
+          <a:prstGeom prst="roundRect">
+            <a:avLst>
+              <a:gd name="adj" fmla="val 40000"/>
+            </a:avLst>
+          </a:prstGeom>
+          <a:solidFill>
+            <a:srgbClr val="6043A3"/>
+          </a:solidFill>
+          <a:ln>
+            <a:noFill/>
+          </a:ln>
+          <a:effectLst/>
+        </p:spPr>
+        <p:style>
+          <a:lnRef idx="1">
+            <a:schemeClr val="accent1"/>
+          </a:lnRef>
+          <a:fillRef idx="3">
+            <a:schemeClr val="accent1"/>
+          </a:fillRef>
+          <a:effectRef idx="2">
+            <a:schemeClr val="accent1"/>
+          </a:effectRef>
+          <a:fontRef idx="minor">
+            <a:schemeClr val="lt1"/>
+          </a:fontRef>
+        </p:style>
+        <p:txBody>
+          <a:bodyPr rtlCol="0" anchor="ctr"/>
+          <a:lstStyle/>
+          <a:p>
+            <a:pPr algn="ctr"/>
+          </a:p>
+        </p:txBody>
+      </p:sp>
+      <p:sp>
+        <p:nvSpPr>
+          <p:cNvPr id="15" name="TextBox 14"/>
+          <p:cNvSpPr txBox="1"/>
+          <p:nvPr/>
+        </p:nvSpPr>
+        <p:spPr>
+          <a:xfrm>
+            <a:off x="3219533" y="3014000"/>
+            <a:ext cx="2744933" cy="1272000"/>
+          </a:xfrm>
+          <a:prstGeom prst="rect">
+            <a:avLst/>
+          </a:prstGeom>
+          <a:noFill/>
+        </p:spPr>
+        <p:txBody>
+          <a:bodyPr wrap="square" anchor="t" lIns="0" rIns="0" tIns="0" bIns="0">
+            <a:spAutoFit/>
+          </a:bodyPr>
+          <a:lstStyle/>
+          <a:p>
+            <a:pPr algn="l">
+              <a:lnSpc>
+                <a:spcPct val="100000"/>
+              </a:lnSpc>
+              <a:spcBef>
+                <a:spcPts val="0"/>
+              </a:spcBef>
+              <a:spcAft>
+                <a:spcPts val="500"/>
+              </a:spcAft>
+            </a:pPr>
+            <a:r>
+              <a:rPr sz="950" b="1" i="0">
+                <a:solidFill>
+                  <a:srgbClr val="6043A3"/>
+                </a:solidFill>
+                <a:latin typeface="Manrope"/>
+                <a:cs typeface="Manrope"/>
+              </a:rPr>
+              <a:t>FO App Transparency &amp; Self-Serve</a:t>
+            </a:r>
+          </a:p>
+          <a:p>
+            <a:pPr algn="l">
+              <a:lnSpc>
+                <a:spcPct val="105000"/>
+              </a:lnSpc>
+              <a:spcBef>
+                <a:spcPts val="0"/>
+              </a:spcBef>
+              <a:spcAft>
+                <a:spcPts val="100"/>
+              </a:spcAft>
+            </a:pPr>
+            <a:r>
+              <a:rPr sz="760" b="1" i="0">
+                <a:solidFill>
+                  <a:srgbClr val="25303B"/>
+                </a:solidFill>
+                <a:latin typeface="Manrope"/>
+                <a:cs typeface="Manrope"/>
+              </a:rPr>
+              <a:t>Trip Statement — 3-yr ledger tab in FO App  </a:t>
+            </a:r>
+          </a:p>
+          <a:p>
+            <a:pPr algn="l">
+              <a:lnSpc>
+                <a:spcPct val="105000"/>
+              </a:lnSpc>
+              <a:spcBef>
+                <a:spcPts val="0"/>
+              </a:spcBef>
+              <a:spcAft>
+                <a:spcPts val="600"/>
+              </a:spcAft>
+            </a:pPr>
+            <a:r>
+              <a:rPr sz="720" b="0" i="1">
+                <a:solidFill>
+                  <a:srgbClr val="6B7480"/>
+                </a:solidFill>
+                <a:latin typeface="Manrope"/>
+                <a:cs typeface="Manrope"/>
+              </a:rPr>
+              <a:t>statement views ↑; fewer payment-status tickets</a:t>
+            </a:r>
+          </a:p>
+          <a:p>
+            <a:pPr algn="l">
+              <a:lnSpc>
+                <a:spcPct val="105000"/>
+              </a:lnSpc>
+              <a:spcBef>
+                <a:spcPts val="0"/>
+              </a:spcBef>
+              <a:spcAft>
+                <a:spcPts val="100"/>
+              </a:spcAft>
+            </a:pPr>
+            <a:r>
+              <a:rPr sz="760" b="1" i="0">
+                <a:solidFill>
+                  <a:srgbClr val="25303B"/>
+                </a:solidFill>
+                <a:latin typeface="Manrope"/>
+                <a:cs typeface="Manrope"/>
+              </a:rPr>
+              <a:t>TDS rate visibility + self-serve declaration  </a:t>
+            </a:r>
+          </a:p>
+          <a:p>
+            <a:pPr algn="l">
+              <a:lnSpc>
+                <a:spcPct val="105000"/>
+              </a:lnSpc>
+              <a:spcBef>
+                <a:spcPts val="0"/>
+              </a:spcBef>
+              <a:spcAft>
+                <a:spcPts val="600"/>
+              </a:spcAft>
+            </a:pPr>
+            <a:r>
+              <a:rPr sz="720" b="0" i="1">
+                <a:solidFill>
+                  <a:srgbClr val="6B7480"/>
+                </a:solidFill>
+                <a:latin typeface="Manrope"/>
+                <a:cs typeface="Manrope"/>
+              </a:rPr>
+              <a:t>% FOs self-serving TDS ↑; fewer TDS tickets</a:t>
+            </a:r>
+          </a:p>
+        </p:txBody>
+      </p:sp>
+      <p:sp>
+        <p:nvSpPr>
+          <p:cNvPr id="16" name="Rounded Rectangle 15"/>
+          <p:cNvSpPr/>
+          <p:nvPr/>
+        </p:nvSpPr>
+        <p:spPr>
+          <a:xfrm>
+            <a:off x="6050466" y="980000"/>
+            <a:ext cx="2864933" cy="1256000"/>
+          </a:xfrm>
+          <a:prstGeom prst="roundRect">
+            <a:avLst>
+              <a:gd name="adj" fmla="val 9000"/>
+            </a:avLst>
+          </a:prstGeom>
+          <a:solidFill>
+            <a:srgbClr val="F7F8FA"/>
+          </a:solidFill>
+          <a:ln w="6350">
+            <a:solidFill>
+              <a:srgbClr val="D5DAE1"/>
+            </a:solidFill>
+          </a:ln>
+          <a:effectLst/>
+        </p:spPr>
+        <p:style>
+          <a:lnRef idx="1">
+            <a:schemeClr val="accent1"/>
+          </a:lnRef>
+          <a:fillRef idx="3">
+            <a:schemeClr val="accent1"/>
+          </a:fillRef>
+          <a:effectRef idx="2">
+            <a:schemeClr val="accent1"/>
+          </a:effectRef>
+          <a:fontRef idx="minor">
+            <a:schemeClr val="lt1"/>
+          </a:fontRef>
+        </p:style>
+        <p:txBody>
+          <a:bodyPr rtlCol="0" anchor="ctr"/>
+          <a:lstStyle/>
+          <a:p>
+            <a:pPr algn="ctr"/>
+          </a:p>
+        </p:txBody>
+      </p:sp>
+      <p:sp>
+        <p:nvSpPr>
+          <p:cNvPr id="17" name="Rounded Rectangle 16"/>
+          <p:cNvSpPr/>
+          <p:nvPr/>
+        </p:nvSpPr>
+        <p:spPr>
+          <a:xfrm>
+            <a:off x="6068466" y="1002000"/>
+            <a:ext cx="36000" cy="1212000"/>
+          </a:xfrm>
+          <a:prstGeom prst="roundRect">
+            <a:avLst>
+              <a:gd name="adj" fmla="val 40000"/>
+            </a:avLst>
+          </a:prstGeom>
+          <a:solidFill>
+            <a:srgbClr val="9C2B2B"/>
+          </a:solidFill>
+          <a:ln>
+            <a:noFill/>
+          </a:ln>
+          <a:effectLst/>
+        </p:spPr>
+        <p:style>
+          <a:lnRef idx="1">
+            <a:schemeClr val="accent1"/>
+          </a:lnRef>
+          <a:fillRef idx="3">
+            <a:schemeClr val="accent1"/>
+          </a:fillRef>
+          <a:effectRef idx="2">
+            <a:schemeClr val="accent1"/>
+          </a:effectRef>
+          <a:fontRef idx="minor">
+            <a:schemeClr val="lt1"/>
+          </a:fontRef>
+        </p:style>
+        <p:txBody>
+          <a:bodyPr rtlCol="0" anchor="ctr"/>
+          <a:lstStyle/>
+          <a:p>
+            <a:pPr algn="ctr"/>
+          </a:p>
+        </p:txBody>
+      </p:sp>
+      <p:sp>
+        <p:nvSpPr>
+          <p:cNvPr id="18" name="TextBox 17"/>
+          <p:cNvSpPr txBox="1"/>
+          <p:nvPr/>
+        </p:nvSpPr>
+        <p:spPr>
+          <a:xfrm>
+            <a:off x="6130466" y="998000"/>
+            <a:ext cx="2744933" cy="1224000"/>
+          </a:xfrm>
+          <a:prstGeom prst="rect">
+            <a:avLst/>
+          </a:prstGeom>
+          <a:noFill/>
+        </p:spPr>
+        <p:txBody>
+          <a:bodyPr wrap="square" anchor="t" lIns="0" rIns="0" tIns="0" bIns="0">
+            <a:spAutoFit/>
+          </a:bodyPr>
+          <a:lstStyle/>
+          <a:p>
+            <a:pPr algn="l">
+              <a:lnSpc>
+                <a:spcPct val="100000"/>
+              </a:lnSpc>
+              <a:spcBef>
+                <a:spcPts val="0"/>
+              </a:spcBef>
+              <a:spcAft>
+                <a:spcPts val="500"/>
+              </a:spcAft>
+            </a:pPr>
+            <a:r>
+              <a:rPr sz="950" b="1" i="0">
+                <a:solidFill>
+                  <a:srgbClr val="9C2B2B"/>
+                </a:solidFill>
+                <a:latin typeface="Manrope"/>
+                <a:cs typeface="Manrope"/>
+              </a:rPr>
+              <a:t>Risk, Fraud &amp; Exposure Control</a:t>
+            </a:r>
+          </a:p>
+          <a:p>
+            <a:pPr algn="l">
+              <a:lnSpc>
+                <a:spcPct val="105000"/>
+              </a:lnSpc>
+              <a:spcBef>
+                <a:spcPts val="0"/>
+              </a:spcBef>
+              <a:spcAft>
+                <a:spcPts val="100"/>
+              </a:spcAft>
+            </a:pPr>
+            <a:r>
+              <a:rPr sz="760" b="1" i="0">
+                <a:solidFill>
+                  <a:srgbClr val="25303B"/>
+                </a:solidFill>
+                <a:latin typeface="Manrope"/>
+                <a:cs typeface="Manrope"/>
+              </a:rPr>
+              <a:t>Payment fraud checks (FO / user / bank-detail change)  </a:t>
+            </a:r>
+          </a:p>
+          <a:p>
+            <a:pPr algn="l">
+              <a:lnSpc>
+                <a:spcPct val="105000"/>
+              </a:lnSpc>
+              <a:spcBef>
+                <a:spcPts val="0"/>
+              </a:spcBef>
+              <a:spcAft>
+                <a:spcPts val="600"/>
+              </a:spcAft>
+            </a:pPr>
+            <a:r>
+              <a:rPr sz="720" b="0" i="1">
+                <a:solidFill>
+                  <a:srgbClr val="6B7480"/>
+                </a:solidFill>
+                <a:latin typeface="Manrope"/>
+                <a:cs typeface="Manrope"/>
+              </a:rPr>
+              <a:t>100% payments fraud-screened; releases blocked pre-disbursal</a:t>
+            </a:r>
+          </a:p>
+          <a:p>
+            <a:pPr algn="l">
+              <a:lnSpc>
+                <a:spcPct val="105000"/>
+              </a:lnSpc>
+              <a:spcBef>
+                <a:spcPts val="0"/>
+              </a:spcBef>
+              <a:spcAft>
+                <a:spcPts val="100"/>
+              </a:spcAft>
+            </a:pPr>
+            <a:r>
+              <a:rPr sz="760" b="1" i="0">
+                <a:solidFill>
+                  <a:srgbClr val="25303B"/>
+                </a:solidFill>
+                <a:latin typeface="Manrope"/>
+                <a:cs typeface="Manrope"/>
+              </a:rPr>
+              <a:t>Configurable LSP exposure limit + auto-disable  </a:t>
+            </a:r>
+          </a:p>
+          <a:p>
+            <a:pPr algn="l">
+              <a:lnSpc>
+                <a:spcPct val="105000"/>
+              </a:lnSpc>
+              <a:spcBef>
+                <a:spcPts val="0"/>
+              </a:spcBef>
+              <a:spcAft>
+                <a:spcPts val="600"/>
+              </a:spcAft>
+            </a:pPr>
+            <a:r>
+              <a:rPr sz="720" b="0" i="1">
+                <a:solidFill>
+                  <a:srgbClr val="6B7480"/>
+                </a:solidFill>
+                <a:latin typeface="Manrope"/>
+                <a:cs typeface="Manrope"/>
+              </a:rPr>
+              <a:t>breaches auto-caught &amp; actioned; lower bad-debt risk</a:t>
+            </a:r>
+          </a:p>
+        </p:txBody>
+      </p:sp>
+      <p:sp>
+        <p:nvSpPr>
+          <p:cNvPr id="19" name="Rounded Rectangle 18"/>
+          <p:cNvSpPr/>
+          <p:nvPr/>
+        </p:nvSpPr>
+        <p:spPr>
+          <a:xfrm>
+            <a:off x="6050466" y="2296000"/>
+            <a:ext cx="2864933" cy="628000"/>
+          </a:xfrm>
+          <a:prstGeom prst="roundRect">
+            <a:avLst>
+              <a:gd name="adj" fmla="val 9000"/>
+            </a:avLst>
+          </a:prstGeom>
+          <a:solidFill>
+            <a:srgbClr val="F7F8FA"/>
+          </a:solidFill>
+          <a:ln w="6350">
+            <a:solidFill>
+              <a:srgbClr val="D5DAE1"/>
+            </a:solidFill>
+          </a:ln>
+          <a:effectLst/>
+        </p:spPr>
+        <p:style>
+          <a:lnRef idx="1">
+            <a:schemeClr val="accent1"/>
+          </a:lnRef>
+          <a:fillRef idx="3">
+            <a:schemeClr val="accent1"/>
+          </a:fillRef>
+          <a:effectRef idx="2">
+            <a:schemeClr val="accent1"/>
+          </a:effectRef>
+          <a:fontRef idx="minor">
+            <a:schemeClr val="lt1"/>
+          </a:fontRef>
+        </p:style>
+        <p:txBody>
+          <a:bodyPr rtlCol="0" anchor="ctr"/>
+          <a:lstStyle/>
+          <a:p>
+            <a:pPr algn="ctr"/>
+          </a:p>
+        </p:txBody>
+      </p:sp>
+      <p:sp>
+        <p:nvSpPr>
+          <p:cNvPr id="20" name="Rounded Rectangle 19"/>
+          <p:cNvSpPr/>
+          <p:nvPr/>
+        </p:nvSpPr>
+        <p:spPr>
+          <a:xfrm>
+            <a:off x="6068466" y="2318000"/>
+            <a:ext cx="36000" cy="584000"/>
+          </a:xfrm>
+          <a:prstGeom prst="roundRect">
+            <a:avLst>
+              <a:gd name="adj" fmla="val 40000"/>
+            </a:avLst>
+          </a:prstGeom>
+          <a:solidFill>
+            <a:srgbClr val="0F766E"/>
+          </a:solidFill>
+          <a:ln>
+            <a:noFill/>
+          </a:ln>
+          <a:effectLst/>
+        </p:spPr>
+        <p:style>
+          <a:lnRef idx="1">
+            <a:schemeClr val="accent1"/>
+          </a:lnRef>
+          <a:fillRef idx="3">
+            <a:schemeClr val="accent1"/>
+          </a:fillRef>
+          <a:effectRef idx="2">
+            <a:schemeClr val="accent1"/>
+          </a:effectRef>
+          <a:fontRef idx="minor">
+            <a:schemeClr val="lt1"/>
+          </a:fontRef>
+        </p:style>
+        <p:txBody>
+          <a:bodyPr rtlCol="0" anchor="ctr"/>
+          <a:lstStyle/>
+          <a:p>
+            <a:pPr algn="ctr"/>
+          </a:p>
+        </p:txBody>
+      </p:sp>
+      <p:sp>
+        <p:nvSpPr>
+          <p:cNvPr id="21" name="TextBox 20"/>
+          <p:cNvSpPr txBox="1"/>
+          <p:nvPr/>
+        </p:nvSpPr>
+        <p:spPr>
+          <a:xfrm>
+            <a:off x="6130466" y="2314000"/>
+            <a:ext cx="2744933" cy="596000"/>
+          </a:xfrm>
+          <a:prstGeom prst="rect">
+            <a:avLst/>
+          </a:prstGeom>
+          <a:noFill/>
+        </p:spPr>
+        <p:txBody>
+          <a:bodyPr wrap="square" anchor="t" lIns="0" rIns="0" tIns="0" bIns="0">
+            <a:spAutoFit/>
+          </a:bodyPr>
+          <a:lstStyle/>
+          <a:p>
+            <a:pPr algn="l">
+              <a:lnSpc>
+                <a:spcPct val="100000"/>
+              </a:lnSpc>
+              <a:spcBef>
+                <a:spcPts val="0"/>
+              </a:spcBef>
+              <a:spcAft>
+                <a:spcPts val="500"/>
+              </a:spcAft>
+            </a:pPr>
+            <a:r>
+              <a:rPr sz="950" b="1" i="0">
+                <a:solidFill>
+                  <a:srgbClr val="0F766E"/>
+                </a:solidFill>
+                <a:latin typeface="Manrope"/>
+                <a:cs typeface="Manrope"/>
+              </a:rPr>
+              <a:t>POD Collection &amp; Audit</a:t>
+            </a:r>
+          </a:p>
+          <a:p>
+            <a:pPr algn="l">
+              <a:lnSpc>
+                <a:spcPct val="105000"/>
+              </a:lnSpc>
+              <a:spcBef>
+                <a:spcPts val="0"/>
+              </a:spcBef>
+              <a:spcAft>
+                <a:spcPts val="100"/>
+              </a:spcAft>
+            </a:pPr>
+            <a:r>
+              <a:rPr sz="760" b="1" i="0">
+                <a:solidFill>
+                  <a:srgbClr val="25303B"/>
+                </a:solidFill>
+                <a:latin typeface="Manrope"/>
+                <a:cs typeface="Manrope"/>
+              </a:rPr>
+              <a:t>Runner App/Mobile page  </a:t>
+            </a:r>
+          </a:p>
+          <a:p>
+            <a:pPr algn="l">
+              <a:lnSpc>
+                <a:spcPct val="105000"/>
+              </a:lnSpc>
+              <a:spcBef>
+                <a:spcPts val="0"/>
+              </a:spcBef>
+              <a:spcAft>
+                <a:spcPts val="600"/>
+              </a:spcAft>
+            </a:pPr>
+            <a:r>
+              <a:rPr sz="720" b="0" i="1">
+                <a:solidFill>
+                  <a:srgbClr val="6B7480"/>
+                </a:solidFill>
+                <a:latin typeface="Manrope"/>
+                <a:cs typeface="Manrope"/>
+              </a:rPr>
+              <a:t>Hard-POD TAT ↓ ≥20%; OCR-audited PODs; faster dispute resolution</a:t>
+            </a:r>
+          </a:p>
+        </p:txBody>
+      </p:sp>
+      <p:sp>
+        <p:nvSpPr>
+          <p:cNvPr id="22" name="Rounded Rectangle 21"/>
+          <p:cNvSpPr/>
+          <p:nvPr/>
+        </p:nvSpPr>
+        <p:spPr>
+          <a:xfrm>
+            <a:off x="6050466" y="2984000"/>
+            <a:ext cx="2864933" cy="628000"/>
+          </a:xfrm>
+          <a:prstGeom prst="roundRect">
+            <a:avLst>
+              <a:gd name="adj" fmla="val 9000"/>
+            </a:avLst>
+          </a:prstGeom>
+          <a:solidFill>
+            <a:srgbClr val="F7F8FA"/>
+          </a:solidFill>
+          <a:ln w="6350">
+            <a:solidFill>
+              <a:srgbClr val="D5DAE1"/>
+            </a:solidFill>
+          </a:ln>
+          <a:effectLst/>
+        </p:spPr>
+        <p:style>
+          <a:lnRef idx="1">
+            <a:schemeClr val="accent1"/>
+          </a:lnRef>
+          <a:fillRef idx="3">
+            <a:schemeClr val="accent1"/>
+          </a:fillRef>
+          <a:effectRef idx="2">
+            <a:schemeClr val="accent1"/>
+          </a:effectRef>
+          <a:fontRef idx="minor">
+            <a:schemeClr val="lt1"/>
+          </a:fontRef>
+        </p:style>
+        <p:txBody>
+          <a:bodyPr rtlCol="0" anchor="ctr"/>
+          <a:lstStyle/>
+          <a:p>
+            <a:pPr algn="ctr"/>
+          </a:p>
+        </p:txBody>
+      </p:sp>
+      <p:sp>
+        <p:nvSpPr>
+          <p:cNvPr id="23" name="Rounded Rectangle 22"/>
+          <p:cNvSpPr/>
+          <p:nvPr/>
+        </p:nvSpPr>
+        <p:spPr>
+          <a:xfrm>
+            <a:off x="6068466" y="3006000"/>
+            <a:ext cx="36000" cy="584000"/>
+          </a:xfrm>
+          <a:prstGeom prst="roundRect">
+            <a:avLst>
+              <a:gd name="adj" fmla="val 40000"/>
+            </a:avLst>
+          </a:prstGeom>
+          <a:solidFill>
+            <a:srgbClr val="1D6FA5"/>
+          </a:solidFill>
+          <a:ln>
+            <a:noFill/>
+          </a:ln>
+          <a:effectLst/>
+        </p:spPr>
+        <p:style>
+          <a:lnRef idx="1">
+            <a:schemeClr val="accent1"/>
+          </a:lnRef>
+          <a:fillRef idx="3">
+            <a:schemeClr val="accent1"/>
+          </a:fillRef>
+          <a:effectRef idx="2">
+            <a:schemeClr val="accent1"/>
+          </a:effectRef>
+          <a:fontRef idx="minor">
+            <a:schemeClr val="lt1"/>
+          </a:fontRef>
+        </p:style>
+        <p:txBody>
+          <a:bodyPr rtlCol="0" anchor="ctr"/>
+          <a:lstStyle/>
+          <a:p>
+            <a:pPr algn="ctr"/>
+          </a:p>
+        </p:txBody>
+      </p:sp>
+      <p:sp>
+        <p:nvSpPr>
+          <p:cNvPr id="24" name="TextBox 23"/>
+          <p:cNvSpPr txBox="1"/>
+          <p:nvPr/>
+        </p:nvSpPr>
+        <p:spPr>
+          <a:xfrm>
+            <a:off x="6130466" y="3002000"/>
+            <a:ext cx="2744933" cy="596000"/>
+          </a:xfrm>
+          <a:prstGeom prst="rect">
+            <a:avLst/>
+          </a:prstGeom>
+          <a:noFill/>
+        </p:spPr>
+        <p:txBody>
+          <a:bodyPr wrap="square" anchor="t" lIns="0" rIns="0" tIns="0" bIns="0">
+            <a:spAutoFit/>
+          </a:bodyPr>
+          <a:lstStyle/>
+          <a:p>
+            <a:pPr algn="l">
+              <a:lnSpc>
+                <a:spcPct val="100000"/>
+              </a:lnSpc>
+              <a:spcBef>
+                <a:spcPts val="0"/>
+              </a:spcBef>
+              <a:spcAft>
+                <a:spcPts val="500"/>
+              </a:spcAft>
+            </a:pPr>
+            <a:r>
+              <a:rPr sz="950" b="1" i="0">
+                <a:solidFill>
+                  <a:srgbClr val="1D6FA5"/>
+                </a:solidFill>
+                <a:latin typeface="Manrope"/>
+                <a:cs typeface="Manrope"/>
+              </a:rPr>
+              <a:t>LSP Experience &amp; Visibility</a:t>
+            </a:r>
+          </a:p>
+          <a:p>
+            <a:pPr algn="l">
+              <a:lnSpc>
+                <a:spcPct val="105000"/>
+              </a:lnSpc>
+              <a:spcBef>
+                <a:spcPts val="0"/>
+              </a:spcBef>
+              <a:spcAft>
+                <a:spcPts val="100"/>
+              </a:spcAft>
+            </a:pPr>
+            <a:r>
+              <a:rPr sz="760" b="1" i="0">
+                <a:solidFill>
+                  <a:srgbClr val="25303B"/>
+                </a:solidFill>
+                <a:latin typeface="Manrope"/>
+                <a:cs typeface="Manrope"/>
+              </a:rPr>
+              <a:t>LSP App  </a:t>
+            </a:r>
+          </a:p>
+          <a:p>
+            <a:pPr algn="l">
+              <a:lnSpc>
+                <a:spcPct val="105000"/>
+              </a:lnSpc>
+              <a:spcBef>
+                <a:spcPts val="0"/>
+              </a:spcBef>
+              <a:spcAft>
+                <a:spcPts val="600"/>
+              </a:spcAft>
+            </a:pPr>
+            <a:r>
+              <a:rPr sz="720" b="0" i="1">
+                <a:solidFill>
+                  <a:srgbClr val="6B7480"/>
+                </a:solidFill>
+                <a:latin typeface="Manrope"/>
+                <a:cs typeface="Manrope"/>
+              </a:rPr>
+              <a:t>self-serve trip/tracking/POD status + ticketing; fewer inbound status calls</a:t>
+            </a:r>
+          </a:p>
+        </p:txBody>
+      </p:sp>
+      <p:sp>
+        <p:nvSpPr>
+          <p:cNvPr id="25" name="Rounded Rectangle 24"/>
+          <p:cNvSpPr/>
+          <p:nvPr/>
+        </p:nvSpPr>
+        <p:spPr>
+          <a:xfrm>
+            <a:off x="6050466" y="3672000"/>
+            <a:ext cx="2864933" cy="628000"/>
+          </a:xfrm>
+          <a:prstGeom prst="roundRect">
+            <a:avLst>
+              <a:gd name="adj" fmla="val 9000"/>
+            </a:avLst>
+          </a:prstGeom>
+          <a:solidFill>
+            <a:srgbClr val="F7F8FA"/>
+          </a:solidFill>
+          <a:ln w="6350">
+            <a:solidFill>
+              <a:srgbClr val="D5DAE1"/>
+            </a:solidFill>
+          </a:ln>
+          <a:effectLst/>
+        </p:spPr>
+        <p:style>
+          <a:lnRef idx="1">
+            <a:schemeClr val="accent1"/>
+          </a:lnRef>
+          <a:fillRef idx="3">
+            <a:schemeClr val="accent1"/>
+          </a:fillRef>
+          <a:effectRef idx="2">
+            <a:schemeClr val="accent1"/>
+          </a:effectRef>
+          <a:fontRef idx="minor">
+            <a:schemeClr val="lt1"/>
+          </a:fontRef>
+        </p:style>
+        <p:txBody>
+          <a:bodyPr rtlCol="0" anchor="ctr"/>
+          <a:lstStyle/>
+          <a:p>
+            <a:pPr algn="ctr"/>
+          </a:p>
+        </p:txBody>
+      </p:sp>
+      <p:sp>
+        <p:nvSpPr>
+          <p:cNvPr id="26" name="Rounded Rectangle 25"/>
+          <p:cNvSpPr/>
+          <p:nvPr/>
+        </p:nvSpPr>
+        <p:spPr>
+          <a:xfrm>
+            <a:off x="6068466" y="3694000"/>
+            <a:ext cx="36000" cy="584000"/>
+          </a:xfrm>
+          <a:prstGeom prst="roundRect">
+            <a:avLst>
+              <a:gd name="adj" fmla="val 40000"/>
+            </a:avLst>
+          </a:prstGeom>
+          <a:solidFill>
+            <a:srgbClr val="C77D0A"/>
+          </a:solidFill>
+          <a:ln>
+            <a:noFill/>
+          </a:ln>
+          <a:effectLst/>
+        </p:spPr>
+        <p:style>
+          <a:lnRef idx="1">
+            <a:schemeClr val="accent1"/>
+          </a:lnRef>
+          <a:fillRef idx="3">
+            <a:schemeClr val="accent1"/>
+          </a:fillRef>
+          <a:effectRef idx="2">
+            <a:schemeClr val="accent1"/>
+          </a:effectRef>
+          <a:fontRef idx="minor">
+            <a:schemeClr val="lt1"/>
+          </a:fontRef>
+        </p:style>
+        <p:txBody>
+          <a:bodyPr rtlCol="0" anchor="ctr"/>
+          <a:lstStyle/>
+          <a:p>
+            <a:pPr algn="ctr"/>
+          </a:p>
+        </p:txBody>
+      </p:sp>
+      <p:sp>
+        <p:nvSpPr>
+          <p:cNvPr id="27" name="TextBox 26"/>
+          <p:cNvSpPr txBox="1"/>
+          <p:nvPr/>
+        </p:nvSpPr>
+        <p:spPr>
+          <a:xfrm>
+            <a:off x="6130466" y="3690000"/>
+            <a:ext cx="2744933" cy="596000"/>
+          </a:xfrm>
+          <a:prstGeom prst="rect">
+            <a:avLst/>
+          </a:prstGeom>
+          <a:noFill/>
+        </p:spPr>
+        <p:txBody>
+          <a:bodyPr wrap="square" anchor="t" lIns="0" rIns="0" tIns="0" bIns="0">
+            <a:spAutoFit/>
+          </a:bodyPr>
+          <a:lstStyle/>
+          <a:p>
+            <a:pPr algn="l">
+              <a:lnSpc>
+                <a:spcPct val="100000"/>
+              </a:lnSpc>
+              <a:spcBef>
+                <a:spcPts val="0"/>
+              </a:spcBef>
+              <a:spcAft>
+                <a:spcPts val="500"/>
+              </a:spcAft>
+            </a:pPr>
+            <a:r>
+              <a:rPr sz="950" b="1" i="0">
+                <a:solidFill>
+                  <a:srgbClr val="C77D0A"/>
+                </a:solidFill>
+                <a:latin typeface="Manrope"/>
+                <a:cs typeface="Manrope"/>
+              </a:rPr>
+              <a:t>Support &amp; Ops Automation</a:t>
+            </a:r>
+          </a:p>
+          <a:p>
+            <a:pPr algn="l">
+              <a:lnSpc>
+                <a:spcPct val="105000"/>
+              </a:lnSpc>
+              <a:spcBef>
+                <a:spcPts val="0"/>
+              </a:spcBef>
+              <a:spcAft>
+                <a:spcPts val="100"/>
+              </a:spcAft>
+            </a:pPr>
+            <a:r>
+              <a:rPr sz="760" b="1" i="0">
+                <a:solidFill>
+                  <a:srgbClr val="25303B"/>
+                </a:solidFill>
+                <a:latin typeface="Manrope"/>
+                <a:cs typeface="Manrope"/>
+              </a:rPr>
+              <a:t>Ticketing for FOs not on the app  </a:t>
+            </a:r>
+          </a:p>
+          <a:p>
+            <a:pPr algn="l">
+              <a:lnSpc>
+                <a:spcPct val="105000"/>
+              </a:lnSpc>
+              <a:spcBef>
+                <a:spcPts val="0"/>
+              </a:spcBef>
+              <a:spcAft>
+                <a:spcPts val="600"/>
+              </a:spcAft>
+            </a:pPr>
+            <a:r>
+              <a:rPr sz="720" b="0" i="1">
+                <a:solidFill>
+                  <a:srgbClr val="6B7480"/>
+                </a:solidFill>
+                <a:latin typeface="Manrope"/>
+                <a:cs typeface="Manrope"/>
+              </a:rPr>
+              <a:t>WhatsApp/IVR/agent — broader off-app support coverage</a:t>
+            </a:r>
+          </a:p>
+        </p:txBody>
+      </p:sp>
     </p:spTree>
   </p:cSld>
   <p:clrMapOvr>

</xml_diff>